<commit_message>
02-03-2026 - Weekly Update
</commit_message>
<xml_diff>
--- a/Website pic standardization.pptx
+++ b/Website pic standardization.pptx
@@ -129,7 +129,7 @@
 <file path=ppt/revisionInfo.xml><?xml version="1.0" encoding="utf-8"?>
 <p1510:revInfo xmlns:a="http://schemas.openxmlformats.org/drawingml/2006/main" xmlns:r="http://schemas.openxmlformats.org/officeDocument/2006/relationships" xmlns:p1510="http://schemas.microsoft.com/office/powerpoint/2015/10/main">
   <p1510:revLst>
-    <p1510:client id="{C5CA0109-A9E6-4582-9323-2954A8A14E8B}" v="4" dt="2026-02-04T12:41:47.157"/>
+    <p1510:client id="{35689674-3667-4C05-8271-F9F74B4BE6DC}" v="19" dt="2026-03-02T13:32:46.075"/>
   </p1510:revLst>
 </p1510:revInfo>
 </file>
@@ -139,18 +139,18 @@
   <pc:docChgLst>
     <pc:chgData name="Andrea Caspani" userId="7345b5ed-8b71-432a-9bb0-dc2ce0ac91b1" providerId="ADAL" clId="{B76F09E3-2273-4519-9469-188BBF2C42C4}"/>
     <pc:docChg chg="undo custSel modSld">
-      <pc:chgData name="Andrea Caspani" userId="7345b5ed-8b71-432a-9bb0-dc2ce0ac91b1" providerId="ADAL" clId="{B76F09E3-2273-4519-9469-188BBF2C42C4}" dt="2026-02-04T12:41:46.723" v="42" actId="14100"/>
+      <pc:chgData name="Andrea Caspani" userId="7345b5ed-8b71-432a-9bb0-dc2ce0ac91b1" providerId="ADAL" clId="{B76F09E3-2273-4519-9469-188BBF2C42C4}" dt="2026-03-02T13:32:46.075" v="94"/>
       <pc:docMkLst>
         <pc:docMk/>
       </pc:docMkLst>
       <pc:sldChg chg="addSp delSp modSp mod">
-        <pc:chgData name="Andrea Caspani" userId="7345b5ed-8b71-432a-9bb0-dc2ce0ac91b1" providerId="ADAL" clId="{B76F09E3-2273-4519-9469-188BBF2C42C4}" dt="2026-02-04T12:41:46.723" v="42" actId="14100"/>
+        <pc:chgData name="Andrea Caspani" userId="7345b5ed-8b71-432a-9bb0-dc2ce0ac91b1" providerId="ADAL" clId="{B76F09E3-2273-4519-9469-188BBF2C42C4}" dt="2026-03-02T13:32:46.075" v="94"/>
         <pc:sldMkLst>
           <pc:docMk/>
           <pc:sldMk cId="3775944948" sldId="258"/>
         </pc:sldMkLst>
-        <pc:spChg chg="mod">
-          <ac:chgData name="Andrea Caspani" userId="7345b5ed-8b71-432a-9bb0-dc2ce0ac91b1" providerId="ADAL" clId="{B76F09E3-2273-4519-9469-188BBF2C42C4}" dt="2026-02-04T12:41:45.704" v="38" actId="207"/>
+        <pc:spChg chg="add del mod">
+          <ac:chgData name="Andrea Caspani" userId="7345b5ed-8b71-432a-9bb0-dc2ce0ac91b1" providerId="ADAL" clId="{B76F09E3-2273-4519-9469-188BBF2C42C4}" dt="2026-03-02T13:32:36.810" v="84" actId="478"/>
           <ac:spMkLst>
             <pc:docMk/>
             <pc:sldMk cId="3775944948" sldId="258"/>
@@ -158,19 +158,43 @@
           </ac:spMkLst>
         </pc:spChg>
         <pc:grpChg chg="add mod">
-          <ac:chgData name="Andrea Caspani" userId="7345b5ed-8b71-432a-9bb0-dc2ce0ac91b1" providerId="ADAL" clId="{B76F09E3-2273-4519-9469-188BBF2C42C4}" dt="2026-02-04T12:41:45.371" v="36" actId="164"/>
+          <ac:chgData name="Andrea Caspani" userId="7345b5ed-8b71-432a-9bb0-dc2ce0ac91b1" providerId="ADAL" clId="{B76F09E3-2273-4519-9469-188BBF2C42C4}" dt="2026-03-02T13:25:03.803" v="53" actId="164"/>
           <ac:grpSpMkLst>
             <pc:docMk/>
             <pc:sldMk cId="3775944948" sldId="258"/>
-            <ac:grpSpMk id="5" creationId="{6810F48D-28AF-B23B-D084-4104ABFA5835}"/>
+            <ac:grpSpMk id="5" creationId="{31401E25-5F9B-0AC6-C49D-23A23A1EBF3F}"/>
+          </ac:grpSpMkLst>
+        </pc:grpChg>
+        <pc:grpChg chg="add mod">
+          <ac:chgData name="Andrea Caspani" userId="7345b5ed-8b71-432a-9bb0-dc2ce0ac91b1" providerId="ADAL" clId="{B76F09E3-2273-4519-9469-188BBF2C42C4}" dt="2026-03-02T13:32:36.637" v="83" actId="164"/>
+          <ac:grpSpMkLst>
+            <pc:docMk/>
+            <pc:sldMk cId="3775944948" sldId="258"/>
+            <ac:grpSpMk id="9" creationId="{876DDACF-0A53-AF43-5803-EED6B9B5B424}"/>
           </ac:grpSpMkLst>
         </pc:grpChg>
         <pc:picChg chg="add mod">
-          <ac:chgData name="Andrea Caspani" userId="7345b5ed-8b71-432a-9bb0-dc2ce0ac91b1" providerId="ADAL" clId="{B76F09E3-2273-4519-9469-188BBF2C42C4}" dt="2026-02-04T12:41:46.723" v="42" actId="14100"/>
+          <ac:chgData name="Andrea Caspani" userId="7345b5ed-8b71-432a-9bb0-dc2ce0ac91b1" providerId="ADAL" clId="{B76F09E3-2273-4519-9469-188BBF2C42C4}" dt="2026-03-02T13:25:05.351" v="59" actId="1076"/>
           <ac:picMkLst>
             <pc:docMk/>
             <pc:sldMk cId="3775944948" sldId="258"/>
-            <ac:picMk id="3" creationId="{387C6EB6-5920-81A3-B390-8C0DB6BECDFA}"/>
+            <ac:picMk id="3" creationId="{FD580889-EDA9-E578-1855-00822EFB8116}"/>
+          </ac:picMkLst>
+        </pc:picChg>
+        <pc:picChg chg="add mod">
+          <ac:chgData name="Andrea Caspani" userId="7345b5ed-8b71-432a-9bb0-dc2ce0ac91b1" providerId="ADAL" clId="{B76F09E3-2273-4519-9469-188BBF2C42C4}" dt="2026-03-02T13:32:46.075" v="94"/>
+          <ac:picMkLst>
+            <pc:docMk/>
+            <pc:sldMk cId="3775944948" sldId="258"/>
+            <ac:picMk id="7" creationId="{8A68BD01-5256-A184-2D8F-03294BC2872C}"/>
+          </ac:picMkLst>
+        </pc:picChg>
+        <pc:picChg chg="add mod ord">
+          <ac:chgData name="Andrea Caspani" userId="7345b5ed-8b71-432a-9bb0-dc2ce0ac91b1" providerId="ADAL" clId="{B76F09E3-2273-4519-9469-188BBF2C42C4}" dt="2026-03-02T13:32:43.404" v="88" actId="1076"/>
+          <ac:picMkLst>
+            <pc:docMk/>
+            <pc:sldMk cId="3775944948" sldId="258"/>
+            <ac:picMk id="8" creationId="{2C434CCA-AF13-C946-A01A-836B26080479}"/>
           </ac:picMkLst>
         </pc:picChg>
       </pc:sldChg>
@@ -328,7 +352,7 @@
           <a:p>
             <a:fld id="{AED78EE6-7C35-42AA-BCAB-EACF262A9D8B}" type="datetimeFigureOut">
               <a:rPr lang="nl-NL" smtClean="0"/>
-              <a:t>4-2-2026</a:t>
+              <a:t>2-3-2026</a:t>
             </a:fld>
             <a:endParaRPr lang="nl-NL"/>
           </a:p>
@@ -528,7 +552,7 @@
           <a:p>
             <a:fld id="{AED78EE6-7C35-42AA-BCAB-EACF262A9D8B}" type="datetimeFigureOut">
               <a:rPr lang="nl-NL" smtClean="0"/>
-              <a:t>4-2-2026</a:t>
+              <a:t>2-3-2026</a:t>
             </a:fld>
             <a:endParaRPr lang="nl-NL"/>
           </a:p>
@@ -738,7 +762,7 @@
           <a:p>
             <a:fld id="{AED78EE6-7C35-42AA-BCAB-EACF262A9D8B}" type="datetimeFigureOut">
               <a:rPr lang="nl-NL" smtClean="0"/>
-              <a:t>4-2-2026</a:t>
+              <a:t>2-3-2026</a:t>
             </a:fld>
             <a:endParaRPr lang="nl-NL"/>
           </a:p>
@@ -938,7 +962,7 @@
           <a:p>
             <a:fld id="{AED78EE6-7C35-42AA-BCAB-EACF262A9D8B}" type="datetimeFigureOut">
               <a:rPr lang="nl-NL" smtClean="0"/>
-              <a:t>4-2-2026</a:t>
+              <a:t>2-3-2026</a:t>
             </a:fld>
             <a:endParaRPr lang="nl-NL"/>
           </a:p>
@@ -1214,7 +1238,7 @@
           <a:p>
             <a:fld id="{AED78EE6-7C35-42AA-BCAB-EACF262A9D8B}" type="datetimeFigureOut">
               <a:rPr lang="nl-NL" smtClean="0"/>
-              <a:t>4-2-2026</a:t>
+              <a:t>2-3-2026</a:t>
             </a:fld>
             <a:endParaRPr lang="nl-NL"/>
           </a:p>
@@ -1482,7 +1506,7 @@
           <a:p>
             <a:fld id="{AED78EE6-7C35-42AA-BCAB-EACF262A9D8B}" type="datetimeFigureOut">
               <a:rPr lang="nl-NL" smtClean="0"/>
-              <a:t>4-2-2026</a:t>
+              <a:t>2-3-2026</a:t>
             </a:fld>
             <a:endParaRPr lang="nl-NL"/>
           </a:p>
@@ -1897,7 +1921,7 @@
           <a:p>
             <a:fld id="{AED78EE6-7C35-42AA-BCAB-EACF262A9D8B}" type="datetimeFigureOut">
               <a:rPr lang="nl-NL" smtClean="0"/>
-              <a:t>4-2-2026</a:t>
+              <a:t>2-3-2026</a:t>
             </a:fld>
             <a:endParaRPr lang="nl-NL"/>
           </a:p>
@@ -2039,7 +2063,7 @@
           <a:p>
             <a:fld id="{AED78EE6-7C35-42AA-BCAB-EACF262A9D8B}" type="datetimeFigureOut">
               <a:rPr lang="nl-NL" smtClean="0"/>
-              <a:t>4-2-2026</a:t>
+              <a:t>2-3-2026</a:t>
             </a:fld>
             <a:endParaRPr lang="nl-NL"/>
           </a:p>
@@ -2152,7 +2176,7 @@
           <a:p>
             <a:fld id="{AED78EE6-7C35-42AA-BCAB-EACF262A9D8B}" type="datetimeFigureOut">
               <a:rPr lang="nl-NL" smtClean="0"/>
-              <a:t>4-2-2026</a:t>
+              <a:t>2-3-2026</a:t>
             </a:fld>
             <a:endParaRPr lang="nl-NL"/>
           </a:p>
@@ -2465,7 +2489,7 @@
           <a:p>
             <a:fld id="{AED78EE6-7C35-42AA-BCAB-EACF262A9D8B}" type="datetimeFigureOut">
               <a:rPr lang="nl-NL" smtClean="0"/>
-              <a:t>4-2-2026</a:t>
+              <a:t>2-3-2026</a:t>
             </a:fld>
             <a:endParaRPr lang="nl-NL"/>
           </a:p>
@@ -2754,7 +2778,7 @@
           <a:p>
             <a:fld id="{AED78EE6-7C35-42AA-BCAB-EACF262A9D8B}" type="datetimeFigureOut">
               <a:rPr lang="nl-NL" smtClean="0"/>
-              <a:t>4-2-2026</a:t>
+              <a:t>2-3-2026</a:t>
             </a:fld>
             <a:endParaRPr lang="nl-NL"/>
           </a:p>
@@ -2997,7 +3021,7 @@
           <a:p>
             <a:fld id="{AED78EE6-7C35-42AA-BCAB-EACF262A9D8B}" type="datetimeFigureOut">
               <a:rPr lang="nl-NL" smtClean="0"/>
-              <a:t>4-2-2026</a:t>
+              <a:t>2-3-2026</a:t>
             </a:fld>
             <a:endParaRPr lang="nl-NL"/>
           </a:p>

</xml_diff>

<commit_message>
10-03-2026 - Weekly Update
</commit_message>
<xml_diff>
--- a/Website pic standardization.pptx
+++ b/Website pic standardization.pptx
@@ -129,7 +129,7 @@
 <file path=ppt/revisionInfo.xml><?xml version="1.0" encoding="utf-8"?>
 <p1510:revInfo xmlns:a="http://schemas.openxmlformats.org/drawingml/2006/main" xmlns:r="http://schemas.openxmlformats.org/officeDocument/2006/relationships" xmlns:p1510="http://schemas.microsoft.com/office/powerpoint/2015/10/main">
   <p1510:revLst>
-    <p1510:client id="{35689674-3667-4C05-8271-F9F74B4BE6DC}" v="19" dt="2026-03-02T13:32:46.075"/>
+    <p1510:client id="{35689674-3667-4C05-8271-F9F74B4BE6DC}" v="72" dt="2026-03-10T11:09:45.640"/>
   </p1510:revLst>
 </p1510:revInfo>
 </file>
@@ -139,62 +139,62 @@
   <pc:docChgLst>
     <pc:chgData name="Andrea Caspani" userId="7345b5ed-8b71-432a-9bb0-dc2ce0ac91b1" providerId="ADAL" clId="{B76F09E3-2273-4519-9469-188BBF2C42C4}"/>
     <pc:docChg chg="undo custSel modSld">
-      <pc:chgData name="Andrea Caspani" userId="7345b5ed-8b71-432a-9bb0-dc2ce0ac91b1" providerId="ADAL" clId="{B76F09E3-2273-4519-9469-188BBF2C42C4}" dt="2026-03-02T13:32:46.075" v="94"/>
+      <pc:chgData name="Andrea Caspani" userId="7345b5ed-8b71-432a-9bb0-dc2ce0ac91b1" providerId="ADAL" clId="{B76F09E3-2273-4519-9469-188BBF2C42C4}" dt="2026-03-10T11:09:45.640" v="146" actId="478"/>
       <pc:docMkLst>
         <pc:docMk/>
       </pc:docMkLst>
       <pc:sldChg chg="addSp delSp modSp mod">
-        <pc:chgData name="Andrea Caspani" userId="7345b5ed-8b71-432a-9bb0-dc2ce0ac91b1" providerId="ADAL" clId="{B76F09E3-2273-4519-9469-188BBF2C42C4}" dt="2026-03-02T13:32:46.075" v="94"/>
+        <pc:chgData name="Andrea Caspani" userId="7345b5ed-8b71-432a-9bb0-dc2ce0ac91b1" providerId="ADAL" clId="{B76F09E3-2273-4519-9469-188BBF2C42C4}" dt="2026-03-10T11:09:45.640" v="146" actId="478"/>
         <pc:sldMkLst>
           <pc:docMk/>
           <pc:sldMk cId="3775944948" sldId="258"/>
         </pc:sldMkLst>
-        <pc:spChg chg="add del mod">
-          <ac:chgData name="Andrea Caspani" userId="7345b5ed-8b71-432a-9bb0-dc2ce0ac91b1" providerId="ADAL" clId="{B76F09E3-2273-4519-9469-188BBF2C42C4}" dt="2026-03-02T13:32:36.810" v="84" actId="478"/>
+        <pc:spChg chg="add del mod ord topLvl">
+          <ac:chgData name="Andrea Caspani" userId="7345b5ed-8b71-432a-9bb0-dc2ce0ac91b1" providerId="ADAL" clId="{B76F09E3-2273-4519-9469-188BBF2C42C4}" dt="2026-03-10T11:09:42.619" v="142" actId="207"/>
           <ac:spMkLst>
             <pc:docMk/>
             <pc:sldMk cId="3775944948" sldId="258"/>
             <ac:spMk id="4" creationId="{A4B43D83-03A1-8289-E760-4AF948E0C4F9}"/>
           </ac:spMkLst>
         </pc:spChg>
-        <pc:grpChg chg="add mod">
-          <ac:chgData name="Andrea Caspani" userId="7345b5ed-8b71-432a-9bb0-dc2ce0ac91b1" providerId="ADAL" clId="{B76F09E3-2273-4519-9469-188BBF2C42C4}" dt="2026-03-02T13:25:03.803" v="53" actId="164"/>
+        <pc:grpChg chg="add del mod">
+          <ac:chgData name="Andrea Caspani" userId="7345b5ed-8b71-432a-9bb0-dc2ce0ac91b1" providerId="ADAL" clId="{B76F09E3-2273-4519-9469-188BBF2C42C4}" dt="2026-03-10T11:09:42.442" v="141" actId="164"/>
           <ac:grpSpMkLst>
             <pc:docMk/>
             <pc:sldMk cId="3775944948" sldId="258"/>
-            <ac:grpSpMk id="5" creationId="{31401E25-5F9B-0AC6-C49D-23A23A1EBF3F}"/>
+            <ac:grpSpMk id="2" creationId="{FC2D0CC1-9ADC-357F-E615-5E0558435C95}"/>
           </ac:grpSpMkLst>
         </pc:grpChg>
         <pc:grpChg chg="add mod">
-          <ac:chgData name="Andrea Caspani" userId="7345b5ed-8b71-432a-9bb0-dc2ce0ac91b1" providerId="ADAL" clId="{B76F09E3-2273-4519-9469-188BBF2C42C4}" dt="2026-03-02T13:32:36.637" v="83" actId="164"/>
+          <ac:chgData name="Andrea Caspani" userId="7345b5ed-8b71-432a-9bb0-dc2ce0ac91b1" providerId="ADAL" clId="{B76F09E3-2273-4519-9469-188BBF2C42C4}" dt="2026-03-10T11:09:38.193" v="133" actId="164"/>
           <ac:grpSpMkLst>
             <pc:docMk/>
             <pc:sldMk cId="3775944948" sldId="258"/>
-            <ac:grpSpMk id="9" creationId="{876DDACF-0A53-AF43-5803-EED6B9B5B424}"/>
+            <ac:grpSpMk id="5" creationId="{BF316E42-B908-3A1E-FCB7-29E65B704939}"/>
           </ac:grpSpMkLst>
         </pc:grpChg>
         <pc:picChg chg="add mod">
-          <ac:chgData name="Andrea Caspani" userId="7345b5ed-8b71-432a-9bb0-dc2ce0ac91b1" providerId="ADAL" clId="{B76F09E3-2273-4519-9469-188BBF2C42C4}" dt="2026-03-02T13:25:05.351" v="59" actId="1076"/>
+          <ac:chgData name="Andrea Caspani" userId="7345b5ed-8b71-432a-9bb0-dc2ce0ac91b1" providerId="ADAL" clId="{B76F09E3-2273-4519-9469-188BBF2C42C4}" dt="2026-03-10T11:05:01.266" v="110"/>
           <ac:picMkLst>
             <pc:docMk/>
             <pc:sldMk cId="3775944948" sldId="258"/>
-            <ac:picMk id="3" creationId="{FD580889-EDA9-E578-1855-00822EFB8116}"/>
+            <ac:picMk id="3" creationId="{C6955BD1-30BF-2386-3CF5-59401437A739}"/>
+          </ac:picMkLst>
+        </pc:picChg>
+        <pc:picChg chg="add del mod topLvl">
+          <ac:chgData name="Andrea Caspani" userId="7345b5ed-8b71-432a-9bb0-dc2ce0ac91b1" providerId="ADAL" clId="{B76F09E3-2273-4519-9469-188BBF2C42C4}" dt="2026-03-10T11:09:45.640" v="146" actId="478"/>
+          <ac:picMkLst>
+            <pc:docMk/>
+            <pc:sldMk cId="3775944948" sldId="258"/>
+            <ac:picMk id="1026" creationId="{4A2968D1-E8E4-02D7-19E3-51626696051B}"/>
           </ac:picMkLst>
         </pc:picChg>
         <pc:picChg chg="add mod">
-          <ac:chgData name="Andrea Caspani" userId="7345b5ed-8b71-432a-9bb0-dc2ce0ac91b1" providerId="ADAL" clId="{B76F09E3-2273-4519-9469-188BBF2C42C4}" dt="2026-03-02T13:32:46.075" v="94"/>
+          <ac:chgData name="Andrea Caspani" userId="7345b5ed-8b71-432a-9bb0-dc2ce0ac91b1" providerId="ADAL" clId="{B76F09E3-2273-4519-9469-188BBF2C42C4}" dt="2026-03-10T11:09:41.380" v="138" actId="1076"/>
           <ac:picMkLst>
             <pc:docMk/>
             <pc:sldMk cId="3775944948" sldId="258"/>
-            <ac:picMk id="7" creationId="{8A68BD01-5256-A184-2D8F-03294BC2872C}"/>
-          </ac:picMkLst>
-        </pc:picChg>
-        <pc:picChg chg="add mod ord">
-          <ac:chgData name="Andrea Caspani" userId="7345b5ed-8b71-432a-9bb0-dc2ce0ac91b1" providerId="ADAL" clId="{B76F09E3-2273-4519-9469-188BBF2C42C4}" dt="2026-03-02T13:32:43.404" v="88" actId="1076"/>
-          <ac:picMkLst>
-            <pc:docMk/>
-            <pc:sldMk cId="3775944948" sldId="258"/>
-            <ac:picMk id="8" creationId="{2C434CCA-AF13-C946-A01A-836B26080479}"/>
+            <ac:picMk id="1027" creationId="{7F682878-5CC2-5E6C-B0C3-7F3BA54CA2DD}"/>
           </ac:picMkLst>
         </pc:picChg>
       </pc:sldChg>
@@ -352,7 +352,7 @@
           <a:p>
             <a:fld id="{AED78EE6-7C35-42AA-BCAB-EACF262A9D8B}" type="datetimeFigureOut">
               <a:rPr lang="nl-NL" smtClean="0"/>
-              <a:t>2-3-2026</a:t>
+              <a:t>10-3-2026</a:t>
             </a:fld>
             <a:endParaRPr lang="nl-NL"/>
           </a:p>
@@ -552,7 +552,7 @@
           <a:p>
             <a:fld id="{AED78EE6-7C35-42AA-BCAB-EACF262A9D8B}" type="datetimeFigureOut">
               <a:rPr lang="nl-NL" smtClean="0"/>
-              <a:t>2-3-2026</a:t>
+              <a:t>10-3-2026</a:t>
             </a:fld>
             <a:endParaRPr lang="nl-NL"/>
           </a:p>
@@ -762,7 +762,7 @@
           <a:p>
             <a:fld id="{AED78EE6-7C35-42AA-BCAB-EACF262A9D8B}" type="datetimeFigureOut">
               <a:rPr lang="nl-NL" smtClean="0"/>
-              <a:t>2-3-2026</a:t>
+              <a:t>10-3-2026</a:t>
             </a:fld>
             <a:endParaRPr lang="nl-NL"/>
           </a:p>
@@ -962,7 +962,7 @@
           <a:p>
             <a:fld id="{AED78EE6-7C35-42AA-BCAB-EACF262A9D8B}" type="datetimeFigureOut">
               <a:rPr lang="nl-NL" smtClean="0"/>
-              <a:t>2-3-2026</a:t>
+              <a:t>10-3-2026</a:t>
             </a:fld>
             <a:endParaRPr lang="nl-NL"/>
           </a:p>
@@ -1238,7 +1238,7 @@
           <a:p>
             <a:fld id="{AED78EE6-7C35-42AA-BCAB-EACF262A9D8B}" type="datetimeFigureOut">
               <a:rPr lang="nl-NL" smtClean="0"/>
-              <a:t>2-3-2026</a:t>
+              <a:t>10-3-2026</a:t>
             </a:fld>
             <a:endParaRPr lang="nl-NL"/>
           </a:p>
@@ -1506,7 +1506,7 @@
           <a:p>
             <a:fld id="{AED78EE6-7C35-42AA-BCAB-EACF262A9D8B}" type="datetimeFigureOut">
               <a:rPr lang="nl-NL" smtClean="0"/>
-              <a:t>2-3-2026</a:t>
+              <a:t>10-3-2026</a:t>
             </a:fld>
             <a:endParaRPr lang="nl-NL"/>
           </a:p>
@@ -1921,7 +1921,7 @@
           <a:p>
             <a:fld id="{AED78EE6-7C35-42AA-BCAB-EACF262A9D8B}" type="datetimeFigureOut">
               <a:rPr lang="nl-NL" smtClean="0"/>
-              <a:t>2-3-2026</a:t>
+              <a:t>10-3-2026</a:t>
             </a:fld>
             <a:endParaRPr lang="nl-NL"/>
           </a:p>
@@ -2063,7 +2063,7 @@
           <a:p>
             <a:fld id="{AED78EE6-7C35-42AA-BCAB-EACF262A9D8B}" type="datetimeFigureOut">
               <a:rPr lang="nl-NL" smtClean="0"/>
-              <a:t>2-3-2026</a:t>
+              <a:t>10-3-2026</a:t>
             </a:fld>
             <a:endParaRPr lang="nl-NL"/>
           </a:p>
@@ -2176,7 +2176,7 @@
           <a:p>
             <a:fld id="{AED78EE6-7C35-42AA-BCAB-EACF262A9D8B}" type="datetimeFigureOut">
               <a:rPr lang="nl-NL" smtClean="0"/>
-              <a:t>2-3-2026</a:t>
+              <a:t>10-3-2026</a:t>
             </a:fld>
             <a:endParaRPr lang="nl-NL"/>
           </a:p>
@@ -2489,7 +2489,7 @@
           <a:p>
             <a:fld id="{AED78EE6-7C35-42AA-BCAB-EACF262A9D8B}" type="datetimeFigureOut">
               <a:rPr lang="nl-NL" smtClean="0"/>
-              <a:t>2-3-2026</a:t>
+              <a:t>10-3-2026</a:t>
             </a:fld>
             <a:endParaRPr lang="nl-NL"/>
           </a:p>
@@ -2778,7 +2778,7 @@
           <a:p>
             <a:fld id="{AED78EE6-7C35-42AA-BCAB-EACF262A9D8B}" type="datetimeFigureOut">
               <a:rPr lang="nl-NL" smtClean="0"/>
-              <a:t>2-3-2026</a:t>
+              <a:t>10-3-2026</a:t>
             </a:fld>
             <a:endParaRPr lang="nl-NL"/>
           </a:p>
@@ -3021,7 +3021,7 @@
           <a:p>
             <a:fld id="{AED78EE6-7C35-42AA-BCAB-EACF262A9D8B}" type="datetimeFigureOut">
               <a:rPr lang="nl-NL" smtClean="0"/>
-              <a:t>2-3-2026</a:t>
+              <a:t>10-3-2026</a:t>
             </a:fld>
             <a:endParaRPr lang="nl-NL"/>
           </a:p>

</xml_diff>

<commit_message>
27-03-2026 - Weekly Update
</commit_message>
<xml_diff>
--- a/Website pic standardization.pptx
+++ b/Website pic standardization.pptx
@@ -139,62 +139,54 @@
   <pc:docChgLst>
     <pc:chgData name="Andrea Caspani" userId="7345b5ed-8b71-432a-9bb0-dc2ce0ac91b1" providerId="ADAL" clId="{B76F09E3-2273-4519-9469-188BBF2C42C4}"/>
     <pc:docChg chg="undo custSel modSld">
-      <pc:chgData name="Andrea Caspani" userId="7345b5ed-8b71-432a-9bb0-dc2ce0ac91b1" providerId="ADAL" clId="{B76F09E3-2273-4519-9469-188BBF2C42C4}" dt="2026-03-10T11:09:45.640" v="146" actId="478"/>
+      <pc:chgData name="Andrea Caspani" userId="7345b5ed-8b71-432a-9bb0-dc2ce0ac91b1" providerId="ADAL" clId="{B76F09E3-2273-4519-9469-188BBF2C42C4}" dt="2026-03-27T13:51:20.633" v="186" actId="478"/>
       <pc:docMkLst>
         <pc:docMk/>
       </pc:docMkLst>
       <pc:sldChg chg="addSp delSp modSp mod">
-        <pc:chgData name="Andrea Caspani" userId="7345b5ed-8b71-432a-9bb0-dc2ce0ac91b1" providerId="ADAL" clId="{B76F09E3-2273-4519-9469-188BBF2C42C4}" dt="2026-03-10T11:09:45.640" v="146" actId="478"/>
+        <pc:chgData name="Andrea Caspani" userId="7345b5ed-8b71-432a-9bb0-dc2ce0ac91b1" providerId="ADAL" clId="{B76F09E3-2273-4519-9469-188BBF2C42C4}" dt="2026-03-27T13:51:20.633" v="186" actId="478"/>
         <pc:sldMkLst>
           <pc:docMk/>
           <pc:sldMk cId="3775944948" sldId="258"/>
         </pc:sldMkLst>
         <pc:spChg chg="add del mod ord topLvl">
-          <ac:chgData name="Andrea Caspani" userId="7345b5ed-8b71-432a-9bb0-dc2ce0ac91b1" providerId="ADAL" clId="{B76F09E3-2273-4519-9469-188BBF2C42C4}" dt="2026-03-10T11:09:42.619" v="142" actId="207"/>
+          <ac:chgData name="Andrea Caspani" userId="7345b5ed-8b71-432a-9bb0-dc2ce0ac91b1" providerId="ADAL" clId="{B76F09E3-2273-4519-9469-188BBF2C42C4}" dt="2026-03-27T13:51:13.468" v="175" actId="478"/>
           <ac:spMkLst>
             <pc:docMk/>
             <pc:sldMk cId="3775944948" sldId="258"/>
             <ac:spMk id="4" creationId="{A4B43D83-03A1-8289-E760-4AF948E0C4F9}"/>
           </ac:spMkLst>
         </pc:spChg>
-        <pc:grpChg chg="add del mod">
-          <ac:chgData name="Andrea Caspani" userId="7345b5ed-8b71-432a-9bb0-dc2ce0ac91b1" providerId="ADAL" clId="{B76F09E3-2273-4519-9469-188BBF2C42C4}" dt="2026-03-10T11:09:42.442" v="141" actId="164"/>
+        <pc:grpChg chg="add mod">
+          <ac:chgData name="Andrea Caspani" userId="7345b5ed-8b71-432a-9bb0-dc2ce0ac91b1" providerId="ADAL" clId="{B76F09E3-2273-4519-9469-188BBF2C42C4}" dt="2026-03-27T13:51:12.318" v="174" actId="164"/>
           <ac:grpSpMkLst>
             <pc:docMk/>
             <pc:sldMk cId="3775944948" sldId="258"/>
-            <ac:grpSpMk id="2" creationId="{FC2D0CC1-9ADC-357F-E615-5E0558435C95}"/>
-          </ac:grpSpMkLst>
-        </pc:grpChg>
-        <pc:grpChg chg="add mod">
-          <ac:chgData name="Andrea Caspani" userId="7345b5ed-8b71-432a-9bb0-dc2ce0ac91b1" providerId="ADAL" clId="{B76F09E3-2273-4519-9469-188BBF2C42C4}" dt="2026-03-10T11:09:38.193" v="133" actId="164"/>
-          <ac:grpSpMkLst>
-            <pc:docMk/>
-            <pc:sldMk cId="3775944948" sldId="258"/>
-            <ac:grpSpMk id="5" creationId="{BF316E42-B908-3A1E-FCB7-29E65B704939}"/>
+            <ac:grpSpMk id="5" creationId="{298EE77E-E24C-228A-51B4-5C245406CCA9}"/>
           </ac:grpSpMkLst>
         </pc:grpChg>
         <pc:picChg chg="add mod">
-          <ac:chgData name="Andrea Caspani" userId="7345b5ed-8b71-432a-9bb0-dc2ce0ac91b1" providerId="ADAL" clId="{B76F09E3-2273-4519-9469-188BBF2C42C4}" dt="2026-03-10T11:05:01.266" v="110"/>
+          <ac:chgData name="Andrea Caspani" userId="7345b5ed-8b71-432a-9bb0-dc2ce0ac91b1" providerId="ADAL" clId="{B76F09E3-2273-4519-9469-188BBF2C42C4}" dt="2026-03-27T13:51:14.539" v="177" actId="1076"/>
           <ac:picMkLst>
             <pc:docMk/>
             <pc:sldMk cId="3775944948" sldId="258"/>
-            <ac:picMk id="3" creationId="{C6955BD1-30BF-2386-3CF5-59401437A739}"/>
+            <ac:picMk id="2" creationId="{40307779-13EC-A008-1F66-8607D30E1301}"/>
           </ac:picMkLst>
         </pc:picChg>
-        <pc:picChg chg="add del mod topLvl">
-          <ac:chgData name="Andrea Caspani" userId="7345b5ed-8b71-432a-9bb0-dc2ce0ac91b1" providerId="ADAL" clId="{B76F09E3-2273-4519-9469-188BBF2C42C4}" dt="2026-03-10T11:09:45.640" v="146" actId="478"/>
+        <pc:picChg chg="add mod">
+          <ac:chgData name="Andrea Caspani" userId="7345b5ed-8b71-432a-9bb0-dc2ce0ac91b1" providerId="ADAL" clId="{B76F09E3-2273-4519-9469-188BBF2C42C4}" dt="2026-03-27T13:51:13.868" v="176" actId="1076"/>
           <ac:picMkLst>
             <pc:docMk/>
             <pc:sldMk cId="3775944948" sldId="258"/>
-            <ac:picMk id="1026" creationId="{4A2968D1-E8E4-02D7-19E3-51626696051B}"/>
+            <ac:picMk id="3" creationId="{F597B8AB-F577-769A-F18B-ED2FF2B4EE26}"/>
           </ac:picMkLst>
         </pc:picChg>
-        <pc:picChg chg="add mod">
-          <ac:chgData name="Andrea Caspani" userId="7345b5ed-8b71-432a-9bb0-dc2ce0ac91b1" providerId="ADAL" clId="{B76F09E3-2273-4519-9469-188BBF2C42C4}" dt="2026-03-10T11:09:41.380" v="138" actId="1076"/>
+        <pc:picChg chg="add del mod">
+          <ac:chgData name="Andrea Caspani" userId="7345b5ed-8b71-432a-9bb0-dc2ce0ac91b1" providerId="ADAL" clId="{B76F09E3-2273-4519-9469-188BBF2C42C4}" dt="2026-03-27T13:51:20.633" v="186" actId="478"/>
           <ac:picMkLst>
             <pc:docMk/>
             <pc:sldMk cId="3775944948" sldId="258"/>
-            <ac:picMk id="1027" creationId="{7F682878-5CC2-5E6C-B0C3-7F3BA54CA2DD}"/>
+            <ac:picMk id="1026" creationId="{30ABD9DB-3FA0-08EF-E6D2-B5252535CB7B}"/>
           </ac:picMkLst>
         </pc:picChg>
       </pc:sldChg>
@@ -352,7 +344,7 @@
           <a:p>
             <a:fld id="{AED78EE6-7C35-42AA-BCAB-EACF262A9D8B}" type="datetimeFigureOut">
               <a:rPr lang="nl-NL" smtClean="0"/>
-              <a:t>10-3-2026</a:t>
+              <a:t>27-3-2026</a:t>
             </a:fld>
             <a:endParaRPr lang="nl-NL"/>
           </a:p>
@@ -552,7 +544,7 @@
           <a:p>
             <a:fld id="{AED78EE6-7C35-42AA-BCAB-EACF262A9D8B}" type="datetimeFigureOut">
               <a:rPr lang="nl-NL" smtClean="0"/>
-              <a:t>10-3-2026</a:t>
+              <a:t>27-3-2026</a:t>
             </a:fld>
             <a:endParaRPr lang="nl-NL"/>
           </a:p>
@@ -762,7 +754,7 @@
           <a:p>
             <a:fld id="{AED78EE6-7C35-42AA-BCAB-EACF262A9D8B}" type="datetimeFigureOut">
               <a:rPr lang="nl-NL" smtClean="0"/>
-              <a:t>10-3-2026</a:t>
+              <a:t>27-3-2026</a:t>
             </a:fld>
             <a:endParaRPr lang="nl-NL"/>
           </a:p>
@@ -962,7 +954,7 @@
           <a:p>
             <a:fld id="{AED78EE6-7C35-42AA-BCAB-EACF262A9D8B}" type="datetimeFigureOut">
               <a:rPr lang="nl-NL" smtClean="0"/>
-              <a:t>10-3-2026</a:t>
+              <a:t>27-3-2026</a:t>
             </a:fld>
             <a:endParaRPr lang="nl-NL"/>
           </a:p>
@@ -1238,7 +1230,7 @@
           <a:p>
             <a:fld id="{AED78EE6-7C35-42AA-BCAB-EACF262A9D8B}" type="datetimeFigureOut">
               <a:rPr lang="nl-NL" smtClean="0"/>
-              <a:t>10-3-2026</a:t>
+              <a:t>27-3-2026</a:t>
             </a:fld>
             <a:endParaRPr lang="nl-NL"/>
           </a:p>
@@ -1506,7 +1498,7 @@
           <a:p>
             <a:fld id="{AED78EE6-7C35-42AA-BCAB-EACF262A9D8B}" type="datetimeFigureOut">
               <a:rPr lang="nl-NL" smtClean="0"/>
-              <a:t>10-3-2026</a:t>
+              <a:t>27-3-2026</a:t>
             </a:fld>
             <a:endParaRPr lang="nl-NL"/>
           </a:p>
@@ -1921,7 +1913,7 @@
           <a:p>
             <a:fld id="{AED78EE6-7C35-42AA-BCAB-EACF262A9D8B}" type="datetimeFigureOut">
               <a:rPr lang="nl-NL" smtClean="0"/>
-              <a:t>10-3-2026</a:t>
+              <a:t>27-3-2026</a:t>
             </a:fld>
             <a:endParaRPr lang="nl-NL"/>
           </a:p>
@@ -2063,7 +2055,7 @@
           <a:p>
             <a:fld id="{AED78EE6-7C35-42AA-BCAB-EACF262A9D8B}" type="datetimeFigureOut">
               <a:rPr lang="nl-NL" smtClean="0"/>
-              <a:t>10-3-2026</a:t>
+              <a:t>27-3-2026</a:t>
             </a:fld>
             <a:endParaRPr lang="nl-NL"/>
           </a:p>
@@ -2176,7 +2168,7 @@
           <a:p>
             <a:fld id="{AED78EE6-7C35-42AA-BCAB-EACF262A9D8B}" type="datetimeFigureOut">
               <a:rPr lang="nl-NL" smtClean="0"/>
-              <a:t>10-3-2026</a:t>
+              <a:t>27-3-2026</a:t>
             </a:fld>
             <a:endParaRPr lang="nl-NL"/>
           </a:p>
@@ -2489,7 +2481,7 @@
           <a:p>
             <a:fld id="{AED78EE6-7C35-42AA-BCAB-EACF262A9D8B}" type="datetimeFigureOut">
               <a:rPr lang="nl-NL" smtClean="0"/>
-              <a:t>10-3-2026</a:t>
+              <a:t>27-3-2026</a:t>
             </a:fld>
             <a:endParaRPr lang="nl-NL"/>
           </a:p>
@@ -2778,7 +2770,7 @@
           <a:p>
             <a:fld id="{AED78EE6-7C35-42AA-BCAB-EACF262A9D8B}" type="datetimeFigureOut">
               <a:rPr lang="nl-NL" smtClean="0"/>
-              <a:t>10-3-2026</a:t>
+              <a:t>27-3-2026</a:t>
             </a:fld>
             <a:endParaRPr lang="nl-NL"/>
           </a:p>
@@ -3021,7 +3013,7 @@
           <a:p>
             <a:fld id="{AED78EE6-7C35-42AA-BCAB-EACF262A9D8B}" type="datetimeFigureOut">
               <a:rPr lang="nl-NL" smtClean="0"/>
-              <a:t>10-3-2026</a:t>
+              <a:t>27-3-2026</a:t>
             </a:fld>
             <a:endParaRPr lang="nl-NL"/>
           </a:p>

</xml_diff>

<commit_message>
08-04-2026 - Weekly update
</commit_message>
<xml_diff>
--- a/Website pic standardization.pptx
+++ b/Website pic standardization.pptx
@@ -129,7 +129,7 @@
 <file path=ppt/revisionInfo.xml><?xml version="1.0" encoding="utf-8"?>
 <p1510:revInfo xmlns:a="http://schemas.openxmlformats.org/drawingml/2006/main" xmlns:r="http://schemas.openxmlformats.org/officeDocument/2006/relationships" xmlns:p1510="http://schemas.microsoft.com/office/powerpoint/2015/10/main">
   <p1510:revLst>
-    <p1510:client id="{35689674-3667-4C05-8271-F9F74B4BE6DC}" v="72" dt="2026-03-10T11:09:45.640"/>
+    <p1510:client id="{35689674-3667-4C05-8271-F9F74B4BE6DC}" v="78" dt="2026-04-08T08:02:46.866"/>
   </p1510:revLst>
 </p1510:revInfo>
 </file>
@@ -139,18 +139,18 @@
   <pc:docChgLst>
     <pc:chgData name="Andrea Caspani" userId="7345b5ed-8b71-432a-9bb0-dc2ce0ac91b1" providerId="ADAL" clId="{B76F09E3-2273-4519-9469-188BBF2C42C4}"/>
     <pc:docChg chg="undo custSel modSld">
-      <pc:chgData name="Andrea Caspani" userId="7345b5ed-8b71-432a-9bb0-dc2ce0ac91b1" providerId="ADAL" clId="{B76F09E3-2273-4519-9469-188BBF2C42C4}" dt="2026-03-27T13:51:20.633" v="186" actId="478"/>
+      <pc:chgData name="Andrea Caspani" userId="7345b5ed-8b71-432a-9bb0-dc2ce0ac91b1" providerId="ADAL" clId="{B76F09E3-2273-4519-9469-188BBF2C42C4}" dt="2026-04-08T08:02:50.689" v="213" actId="931"/>
       <pc:docMkLst>
         <pc:docMk/>
       </pc:docMkLst>
       <pc:sldChg chg="addSp delSp modSp mod">
-        <pc:chgData name="Andrea Caspani" userId="7345b5ed-8b71-432a-9bb0-dc2ce0ac91b1" providerId="ADAL" clId="{B76F09E3-2273-4519-9469-188BBF2C42C4}" dt="2026-03-27T13:51:20.633" v="186" actId="478"/>
+        <pc:chgData name="Andrea Caspani" userId="7345b5ed-8b71-432a-9bb0-dc2ce0ac91b1" providerId="ADAL" clId="{B76F09E3-2273-4519-9469-188BBF2C42C4}" dt="2026-04-08T08:02:50.689" v="213" actId="931"/>
         <pc:sldMkLst>
           <pc:docMk/>
           <pc:sldMk cId="3775944948" sldId="258"/>
         </pc:sldMkLst>
         <pc:spChg chg="add del mod ord topLvl">
-          <ac:chgData name="Andrea Caspani" userId="7345b5ed-8b71-432a-9bb0-dc2ce0ac91b1" providerId="ADAL" clId="{B76F09E3-2273-4519-9469-188BBF2C42C4}" dt="2026-03-27T13:51:13.468" v="175" actId="478"/>
+          <ac:chgData name="Andrea Caspani" userId="7345b5ed-8b71-432a-9bb0-dc2ce0ac91b1" providerId="ADAL" clId="{B76F09E3-2273-4519-9469-188BBF2C42C4}" dt="2026-04-08T08:02:45.813" v="205" actId="478"/>
           <ac:spMkLst>
             <pc:docMk/>
             <pc:sldMk cId="3775944948" sldId="258"/>
@@ -158,35 +158,27 @@
           </ac:spMkLst>
         </pc:spChg>
         <pc:grpChg chg="add mod">
-          <ac:chgData name="Andrea Caspani" userId="7345b5ed-8b71-432a-9bb0-dc2ce0ac91b1" providerId="ADAL" clId="{B76F09E3-2273-4519-9469-188BBF2C42C4}" dt="2026-03-27T13:51:12.318" v="174" actId="164"/>
+          <ac:chgData name="Andrea Caspani" userId="7345b5ed-8b71-432a-9bb0-dc2ce0ac91b1" providerId="ADAL" clId="{B76F09E3-2273-4519-9469-188BBF2C42C4}" dt="2026-04-08T08:02:45.357" v="203" actId="164"/>
           <ac:grpSpMkLst>
             <pc:docMk/>
             <pc:sldMk cId="3775944948" sldId="258"/>
-            <ac:grpSpMk id="5" creationId="{298EE77E-E24C-228A-51B4-5C245406CCA9}"/>
+            <ac:grpSpMk id="6" creationId="{D4BAD70E-8218-54E2-D053-F0FD88F45091}"/>
           </ac:grpSpMkLst>
         </pc:grpChg>
-        <pc:picChg chg="add mod">
-          <ac:chgData name="Andrea Caspani" userId="7345b5ed-8b71-432a-9bb0-dc2ce0ac91b1" providerId="ADAL" clId="{B76F09E3-2273-4519-9469-188BBF2C42C4}" dt="2026-03-27T13:51:14.539" v="177" actId="1076"/>
+        <pc:picChg chg="add del mod">
+          <ac:chgData name="Andrea Caspani" userId="7345b5ed-8b71-432a-9bb0-dc2ce0ac91b1" providerId="ADAL" clId="{B76F09E3-2273-4519-9469-188BBF2C42C4}" dt="2026-04-08T08:02:50.689" v="213" actId="931"/>
           <ac:picMkLst>
             <pc:docMk/>
             <pc:sldMk cId="3775944948" sldId="258"/>
-            <ac:picMk id="2" creationId="{40307779-13EC-A008-1F66-8607D30E1301}"/>
+            <ac:picMk id="3" creationId="{3CD43D46-640A-EC0A-81E1-D03D4C53DB0E}"/>
           </ac:picMkLst>
         </pc:picChg>
-        <pc:picChg chg="add mod">
-          <ac:chgData name="Andrea Caspani" userId="7345b5ed-8b71-432a-9bb0-dc2ce0ac91b1" providerId="ADAL" clId="{B76F09E3-2273-4519-9469-188BBF2C42C4}" dt="2026-03-27T13:51:13.868" v="176" actId="1076"/>
+        <pc:picChg chg="add del mod ord">
+          <ac:chgData name="Andrea Caspani" userId="7345b5ed-8b71-432a-9bb0-dc2ce0ac91b1" providerId="ADAL" clId="{B76F09E3-2273-4519-9469-188BBF2C42C4}" dt="2026-04-08T08:02:46.386" v="208" actId="1076"/>
           <ac:picMkLst>
             <pc:docMk/>
             <pc:sldMk cId="3775944948" sldId="258"/>
-            <ac:picMk id="3" creationId="{F597B8AB-F577-769A-F18B-ED2FF2B4EE26}"/>
-          </ac:picMkLst>
-        </pc:picChg>
-        <pc:picChg chg="add del mod">
-          <ac:chgData name="Andrea Caspani" userId="7345b5ed-8b71-432a-9bb0-dc2ce0ac91b1" providerId="ADAL" clId="{B76F09E3-2273-4519-9469-188BBF2C42C4}" dt="2026-03-27T13:51:20.633" v="186" actId="478"/>
-          <ac:picMkLst>
-            <pc:docMk/>
-            <pc:sldMk cId="3775944948" sldId="258"/>
-            <ac:picMk id="1026" creationId="{30ABD9DB-3FA0-08EF-E6D2-B5252535CB7B}"/>
+            <ac:picMk id="5" creationId="{2C70ED76-ED30-50C8-0834-FD95DBF120FF}"/>
           </ac:picMkLst>
         </pc:picChg>
       </pc:sldChg>
@@ -344,7 +336,7 @@
           <a:p>
             <a:fld id="{AED78EE6-7C35-42AA-BCAB-EACF262A9D8B}" type="datetimeFigureOut">
               <a:rPr lang="nl-NL" smtClean="0"/>
-              <a:t>27-3-2026</a:t>
+              <a:t>8-4-2026</a:t>
             </a:fld>
             <a:endParaRPr lang="nl-NL"/>
           </a:p>
@@ -544,7 +536,7 @@
           <a:p>
             <a:fld id="{AED78EE6-7C35-42AA-BCAB-EACF262A9D8B}" type="datetimeFigureOut">
               <a:rPr lang="nl-NL" smtClean="0"/>
-              <a:t>27-3-2026</a:t>
+              <a:t>8-4-2026</a:t>
             </a:fld>
             <a:endParaRPr lang="nl-NL"/>
           </a:p>
@@ -754,7 +746,7 @@
           <a:p>
             <a:fld id="{AED78EE6-7C35-42AA-BCAB-EACF262A9D8B}" type="datetimeFigureOut">
               <a:rPr lang="nl-NL" smtClean="0"/>
-              <a:t>27-3-2026</a:t>
+              <a:t>8-4-2026</a:t>
             </a:fld>
             <a:endParaRPr lang="nl-NL"/>
           </a:p>
@@ -954,7 +946,7 @@
           <a:p>
             <a:fld id="{AED78EE6-7C35-42AA-BCAB-EACF262A9D8B}" type="datetimeFigureOut">
               <a:rPr lang="nl-NL" smtClean="0"/>
-              <a:t>27-3-2026</a:t>
+              <a:t>8-4-2026</a:t>
             </a:fld>
             <a:endParaRPr lang="nl-NL"/>
           </a:p>
@@ -1230,7 +1222,7 @@
           <a:p>
             <a:fld id="{AED78EE6-7C35-42AA-BCAB-EACF262A9D8B}" type="datetimeFigureOut">
               <a:rPr lang="nl-NL" smtClean="0"/>
-              <a:t>27-3-2026</a:t>
+              <a:t>8-4-2026</a:t>
             </a:fld>
             <a:endParaRPr lang="nl-NL"/>
           </a:p>
@@ -1498,7 +1490,7 @@
           <a:p>
             <a:fld id="{AED78EE6-7C35-42AA-BCAB-EACF262A9D8B}" type="datetimeFigureOut">
               <a:rPr lang="nl-NL" smtClean="0"/>
-              <a:t>27-3-2026</a:t>
+              <a:t>8-4-2026</a:t>
             </a:fld>
             <a:endParaRPr lang="nl-NL"/>
           </a:p>
@@ -1913,7 +1905,7 @@
           <a:p>
             <a:fld id="{AED78EE6-7C35-42AA-BCAB-EACF262A9D8B}" type="datetimeFigureOut">
               <a:rPr lang="nl-NL" smtClean="0"/>
-              <a:t>27-3-2026</a:t>
+              <a:t>8-4-2026</a:t>
             </a:fld>
             <a:endParaRPr lang="nl-NL"/>
           </a:p>
@@ -2055,7 +2047,7 @@
           <a:p>
             <a:fld id="{AED78EE6-7C35-42AA-BCAB-EACF262A9D8B}" type="datetimeFigureOut">
               <a:rPr lang="nl-NL" smtClean="0"/>
-              <a:t>27-3-2026</a:t>
+              <a:t>8-4-2026</a:t>
             </a:fld>
             <a:endParaRPr lang="nl-NL"/>
           </a:p>
@@ -2168,7 +2160,7 @@
           <a:p>
             <a:fld id="{AED78EE6-7C35-42AA-BCAB-EACF262A9D8B}" type="datetimeFigureOut">
               <a:rPr lang="nl-NL" smtClean="0"/>
-              <a:t>27-3-2026</a:t>
+              <a:t>8-4-2026</a:t>
             </a:fld>
             <a:endParaRPr lang="nl-NL"/>
           </a:p>
@@ -2481,7 +2473,7 @@
           <a:p>
             <a:fld id="{AED78EE6-7C35-42AA-BCAB-EACF262A9D8B}" type="datetimeFigureOut">
               <a:rPr lang="nl-NL" smtClean="0"/>
-              <a:t>27-3-2026</a:t>
+              <a:t>8-4-2026</a:t>
             </a:fld>
             <a:endParaRPr lang="nl-NL"/>
           </a:p>
@@ -2770,7 +2762,7 @@
           <a:p>
             <a:fld id="{AED78EE6-7C35-42AA-BCAB-EACF262A9D8B}" type="datetimeFigureOut">
               <a:rPr lang="nl-NL" smtClean="0"/>
-              <a:t>27-3-2026</a:t>
+              <a:t>8-4-2026</a:t>
             </a:fld>
             <a:endParaRPr lang="nl-NL"/>
           </a:p>
@@ -3013,7 +3005,7 @@
           <a:p>
             <a:fld id="{AED78EE6-7C35-42AA-BCAB-EACF262A9D8B}" type="datetimeFigureOut">
               <a:rPr lang="nl-NL" smtClean="0"/>
-              <a:t>27-3-2026</a:t>
+              <a:t>8-4-2026</a:t>
             </a:fld>
             <a:endParaRPr lang="nl-NL"/>
           </a:p>

</xml_diff>

<commit_message>
14-04-2026 - Weekly update
</commit_message>
<xml_diff>
--- a/Website pic standardization.pptx
+++ b/Website pic standardization.pptx
@@ -129,7 +129,7 @@
 <file path=ppt/revisionInfo.xml><?xml version="1.0" encoding="utf-8"?>
 <p1510:revInfo xmlns:a="http://schemas.openxmlformats.org/drawingml/2006/main" xmlns:r="http://schemas.openxmlformats.org/officeDocument/2006/relationships" xmlns:p1510="http://schemas.microsoft.com/office/powerpoint/2015/10/main">
   <p1510:revLst>
-    <p1510:client id="{35689674-3667-4C05-8271-F9F74B4BE6DC}" v="78" dt="2026-04-08T08:02:46.866"/>
+    <p1510:client id="{35689674-3667-4C05-8271-F9F74B4BE6DC}" v="102" dt="2026-04-14T08:42:54.984"/>
   </p1510:revLst>
 </p1510:revInfo>
 </file>
@@ -139,18 +139,18 @@
   <pc:docChgLst>
     <pc:chgData name="Andrea Caspani" userId="7345b5ed-8b71-432a-9bb0-dc2ce0ac91b1" providerId="ADAL" clId="{B76F09E3-2273-4519-9469-188BBF2C42C4}"/>
     <pc:docChg chg="undo custSel modSld">
-      <pc:chgData name="Andrea Caspani" userId="7345b5ed-8b71-432a-9bb0-dc2ce0ac91b1" providerId="ADAL" clId="{B76F09E3-2273-4519-9469-188BBF2C42C4}" dt="2026-04-08T08:02:50.689" v="213" actId="931"/>
+      <pc:chgData name="Andrea Caspani" userId="7345b5ed-8b71-432a-9bb0-dc2ce0ac91b1" providerId="ADAL" clId="{B76F09E3-2273-4519-9469-188BBF2C42C4}" dt="2026-04-14T08:43:00.617" v="292" actId="478"/>
       <pc:docMkLst>
         <pc:docMk/>
       </pc:docMkLst>
       <pc:sldChg chg="addSp delSp modSp mod">
-        <pc:chgData name="Andrea Caspani" userId="7345b5ed-8b71-432a-9bb0-dc2ce0ac91b1" providerId="ADAL" clId="{B76F09E3-2273-4519-9469-188BBF2C42C4}" dt="2026-04-08T08:02:50.689" v="213" actId="931"/>
+        <pc:chgData name="Andrea Caspani" userId="7345b5ed-8b71-432a-9bb0-dc2ce0ac91b1" providerId="ADAL" clId="{B76F09E3-2273-4519-9469-188BBF2C42C4}" dt="2026-04-14T08:43:00.617" v="292" actId="478"/>
         <pc:sldMkLst>
           <pc:docMk/>
           <pc:sldMk cId="3775944948" sldId="258"/>
         </pc:sldMkLst>
         <pc:spChg chg="add del mod ord topLvl">
-          <ac:chgData name="Andrea Caspani" userId="7345b5ed-8b71-432a-9bb0-dc2ce0ac91b1" providerId="ADAL" clId="{B76F09E3-2273-4519-9469-188BBF2C42C4}" dt="2026-04-08T08:02:45.813" v="205" actId="478"/>
+          <ac:chgData name="Andrea Caspani" userId="7345b5ed-8b71-432a-9bb0-dc2ce0ac91b1" providerId="ADAL" clId="{B76F09E3-2273-4519-9469-188BBF2C42C4}" dt="2026-04-14T08:42:55.417" v="286" actId="207"/>
           <ac:spMkLst>
             <pc:docMk/>
             <pc:sldMk cId="3775944948" sldId="258"/>
@@ -158,27 +158,115 @@
           </ac:spMkLst>
         </pc:spChg>
         <pc:grpChg chg="add mod">
-          <ac:chgData name="Andrea Caspani" userId="7345b5ed-8b71-432a-9bb0-dc2ce0ac91b1" providerId="ADAL" clId="{B76F09E3-2273-4519-9469-188BBF2C42C4}" dt="2026-04-08T08:02:45.357" v="203" actId="164"/>
+          <ac:chgData name="Andrea Caspani" userId="7345b5ed-8b71-432a-9bb0-dc2ce0ac91b1" providerId="ADAL" clId="{B76F09E3-2273-4519-9469-188BBF2C42C4}" dt="2026-04-14T08:41:07.941" v="254" actId="164"/>
           <ac:grpSpMkLst>
             <pc:docMk/>
             <pc:sldMk cId="3775944948" sldId="258"/>
-            <ac:grpSpMk id="6" creationId="{D4BAD70E-8218-54E2-D053-F0FD88F45091}"/>
+            <ac:grpSpMk id="15" creationId="{F0144A51-A481-7937-BDBC-F132A67F2CEA}"/>
           </ac:grpSpMkLst>
         </pc:grpChg>
-        <pc:picChg chg="add del mod">
-          <ac:chgData name="Andrea Caspani" userId="7345b5ed-8b71-432a-9bb0-dc2ce0ac91b1" providerId="ADAL" clId="{B76F09E3-2273-4519-9469-188BBF2C42C4}" dt="2026-04-08T08:02:50.689" v="213" actId="931"/>
+        <pc:grpChg chg="add mod">
+          <ac:chgData name="Andrea Caspani" userId="7345b5ed-8b71-432a-9bb0-dc2ce0ac91b1" providerId="ADAL" clId="{B76F09E3-2273-4519-9469-188BBF2C42C4}" dt="2026-04-14T08:42:54.984" v="284" actId="164"/>
+          <ac:grpSpMkLst>
+            <pc:docMk/>
+            <pc:sldMk cId="3775944948" sldId="258"/>
+            <ac:grpSpMk id="18" creationId="{C18FA42D-C5C5-585F-67DD-2CF9FAC5F616}"/>
+          </ac:grpSpMkLst>
+        </pc:grpChg>
+        <pc:picChg chg="add del mod ord">
+          <ac:chgData name="Andrea Caspani" userId="7345b5ed-8b71-432a-9bb0-dc2ce0ac91b1" providerId="ADAL" clId="{B76F09E3-2273-4519-9469-188BBF2C42C4}" dt="2026-04-14T08:41:13.437" v="269" actId="478"/>
           <ac:picMkLst>
             <pc:docMk/>
             <pc:sldMk cId="3775944948" sldId="258"/>
-            <ac:picMk id="3" creationId="{3CD43D46-640A-EC0A-81E1-D03D4C53DB0E}"/>
+            <ac:picMk id="3" creationId="{DD7C83CF-96DB-D7DB-F1C0-212AB9B1EE2A}"/>
+          </ac:picMkLst>
+        </pc:picChg>
+        <pc:picChg chg="add del mod">
+          <ac:chgData name="Andrea Caspani" userId="7345b5ed-8b71-432a-9bb0-dc2ce0ac91b1" providerId="ADAL" clId="{B76F09E3-2273-4519-9469-188BBF2C42C4}" dt="2026-04-14T08:41:14.107" v="270" actId="478"/>
+          <ac:picMkLst>
+            <pc:docMk/>
+            <pc:sldMk cId="3775944948" sldId="258"/>
+            <ac:picMk id="5" creationId="{26F9A092-631B-647E-C4B7-32F7D4F87E1D}"/>
+          </ac:picMkLst>
+        </pc:picChg>
+        <pc:picChg chg="add del mod">
+          <ac:chgData name="Andrea Caspani" userId="7345b5ed-8b71-432a-9bb0-dc2ce0ac91b1" providerId="ADAL" clId="{B76F09E3-2273-4519-9469-188BBF2C42C4}" dt="2026-04-14T08:41:12.643" v="268" actId="478"/>
+          <ac:picMkLst>
+            <pc:docMk/>
+            <pc:sldMk cId="3775944948" sldId="258"/>
+            <ac:picMk id="6" creationId="{F84C1B55-1C3C-3F40-59EF-8D3A0FF89839}"/>
+          </ac:picMkLst>
+        </pc:picChg>
+        <pc:picChg chg="add del mod ord modCrop">
+          <ac:chgData name="Andrea Caspani" userId="7345b5ed-8b71-432a-9bb0-dc2ce0ac91b1" providerId="ADAL" clId="{B76F09E3-2273-4519-9469-188BBF2C42C4}" dt="2026-04-14T08:41:11.035" v="267" actId="478"/>
+          <ac:picMkLst>
+            <pc:docMk/>
+            <pc:sldMk cId="3775944948" sldId="258"/>
+            <ac:picMk id="7" creationId="{0F2DF81F-C03E-C6F1-5B6B-B5183E234934}"/>
+          </ac:picMkLst>
+        </pc:picChg>
+        <pc:picChg chg="add del mod modCrop">
+          <ac:chgData name="Andrea Caspani" userId="7345b5ed-8b71-432a-9bb0-dc2ce0ac91b1" providerId="ADAL" clId="{B76F09E3-2273-4519-9469-188BBF2C42C4}" dt="2026-04-14T08:41:16.232" v="273" actId="478"/>
+          <ac:picMkLst>
+            <pc:docMk/>
+            <pc:sldMk cId="3775944948" sldId="258"/>
+            <ac:picMk id="8" creationId="{D6D02F7B-0AEE-B031-D50F-F099BAF696FF}"/>
+          </ac:picMkLst>
+        </pc:picChg>
+        <pc:picChg chg="add del mod modCrop">
+          <ac:chgData name="Andrea Caspani" userId="7345b5ed-8b71-432a-9bb0-dc2ce0ac91b1" providerId="ADAL" clId="{B76F09E3-2273-4519-9469-188BBF2C42C4}" dt="2026-04-14T08:41:15.550" v="272" actId="478"/>
+          <ac:picMkLst>
+            <pc:docMk/>
+            <pc:sldMk cId="3775944948" sldId="258"/>
+            <ac:picMk id="9" creationId="{A59E1CE6-4E05-7F10-639F-3C80B81348EC}"/>
+          </ac:picMkLst>
+        </pc:picChg>
+        <pc:picChg chg="add del mod">
+          <ac:chgData name="Andrea Caspani" userId="7345b5ed-8b71-432a-9bb0-dc2ce0ac91b1" providerId="ADAL" clId="{B76F09E3-2273-4519-9469-188BBF2C42C4}" dt="2026-04-14T08:41:14.853" v="271" actId="478"/>
+          <ac:picMkLst>
+            <pc:docMk/>
+            <pc:sldMk cId="3775944948" sldId="258"/>
+            <ac:picMk id="10" creationId="{4C0BD197-7F58-9DC1-E21A-9C9C904D1829}"/>
           </ac:picMkLst>
         </pc:picChg>
         <pc:picChg chg="add del mod ord">
-          <ac:chgData name="Andrea Caspani" userId="7345b5ed-8b71-432a-9bb0-dc2ce0ac91b1" providerId="ADAL" clId="{B76F09E3-2273-4519-9469-188BBF2C42C4}" dt="2026-04-08T08:02:46.386" v="208" actId="1076"/>
+          <ac:chgData name="Andrea Caspani" userId="7345b5ed-8b71-432a-9bb0-dc2ce0ac91b1" providerId="ADAL" clId="{B76F09E3-2273-4519-9469-188BBF2C42C4}" dt="2026-04-14T08:43:00.617" v="292" actId="478"/>
           <ac:picMkLst>
             <pc:docMk/>
             <pc:sldMk cId="3775944948" sldId="258"/>
-            <ac:picMk id="5" creationId="{2C70ED76-ED30-50C8-0834-FD95DBF120FF}"/>
+            <ac:picMk id="11" creationId="{722B65EB-910E-06F7-391E-3025A7CF6CDD}"/>
+          </ac:picMkLst>
+        </pc:picChg>
+        <pc:picChg chg="add mod ord">
+          <ac:chgData name="Andrea Caspani" userId="7345b5ed-8b71-432a-9bb0-dc2ce0ac91b1" providerId="ADAL" clId="{B76F09E3-2273-4519-9469-188BBF2C42C4}" dt="2026-04-14T08:41:08.840" v="258" actId="166"/>
+          <ac:picMkLst>
+            <pc:docMk/>
+            <pc:sldMk cId="3775944948" sldId="258"/>
+            <ac:picMk id="12" creationId="{0F2DF81F-C03E-C6F1-5B6B-B5183E234934}"/>
+          </ac:picMkLst>
+        </pc:picChg>
+        <pc:picChg chg="add mod">
+          <ac:chgData name="Andrea Caspani" userId="7345b5ed-8b71-432a-9bb0-dc2ce0ac91b1" providerId="ADAL" clId="{B76F09E3-2273-4519-9469-188BBF2C42C4}" dt="2026-04-14T08:39:56.806" v="249"/>
+          <ac:picMkLst>
+            <pc:docMk/>
+            <pc:sldMk cId="3775944948" sldId="258"/>
+            <ac:picMk id="13" creationId="{DD7C83CF-96DB-D7DB-F1C0-212AB9B1EE2A}"/>
+          </ac:picMkLst>
+        </pc:picChg>
+        <pc:picChg chg="add mod">
+          <ac:chgData name="Andrea Caspani" userId="7345b5ed-8b71-432a-9bb0-dc2ce0ac91b1" providerId="ADAL" clId="{B76F09E3-2273-4519-9469-188BBF2C42C4}" dt="2026-04-14T08:41:07.941" v="254" actId="164"/>
+          <ac:picMkLst>
+            <pc:docMk/>
+            <pc:sldMk cId="3775944948" sldId="258"/>
+            <ac:picMk id="14" creationId="{E67D9297-80AE-F590-48F6-7974A1ED5B6E}"/>
+          </ac:picMkLst>
+        </pc:picChg>
+        <pc:picChg chg="add del mod">
+          <ac:chgData name="Andrea Caspani" userId="7345b5ed-8b71-432a-9bb0-dc2ce0ac91b1" providerId="ADAL" clId="{B76F09E3-2273-4519-9469-188BBF2C42C4}" dt="2026-04-14T08:42:57.310" v="291" actId="931"/>
+          <ac:picMkLst>
+            <pc:docMk/>
+            <pc:sldMk cId="3775944948" sldId="258"/>
+            <ac:picMk id="17" creationId="{FFE0BD10-3350-D124-9E9C-5844F2344546}"/>
           </ac:picMkLst>
         </pc:picChg>
       </pc:sldChg>
@@ -336,7 +424,7 @@
           <a:p>
             <a:fld id="{AED78EE6-7C35-42AA-BCAB-EACF262A9D8B}" type="datetimeFigureOut">
               <a:rPr lang="nl-NL" smtClean="0"/>
-              <a:t>8-4-2026</a:t>
+              <a:t>14-4-2026</a:t>
             </a:fld>
             <a:endParaRPr lang="nl-NL"/>
           </a:p>
@@ -536,7 +624,7 @@
           <a:p>
             <a:fld id="{AED78EE6-7C35-42AA-BCAB-EACF262A9D8B}" type="datetimeFigureOut">
               <a:rPr lang="nl-NL" smtClean="0"/>
-              <a:t>8-4-2026</a:t>
+              <a:t>14-4-2026</a:t>
             </a:fld>
             <a:endParaRPr lang="nl-NL"/>
           </a:p>
@@ -746,7 +834,7 @@
           <a:p>
             <a:fld id="{AED78EE6-7C35-42AA-BCAB-EACF262A9D8B}" type="datetimeFigureOut">
               <a:rPr lang="nl-NL" smtClean="0"/>
-              <a:t>8-4-2026</a:t>
+              <a:t>14-4-2026</a:t>
             </a:fld>
             <a:endParaRPr lang="nl-NL"/>
           </a:p>
@@ -946,7 +1034,7 @@
           <a:p>
             <a:fld id="{AED78EE6-7C35-42AA-BCAB-EACF262A9D8B}" type="datetimeFigureOut">
               <a:rPr lang="nl-NL" smtClean="0"/>
-              <a:t>8-4-2026</a:t>
+              <a:t>14-4-2026</a:t>
             </a:fld>
             <a:endParaRPr lang="nl-NL"/>
           </a:p>
@@ -1222,7 +1310,7 @@
           <a:p>
             <a:fld id="{AED78EE6-7C35-42AA-BCAB-EACF262A9D8B}" type="datetimeFigureOut">
               <a:rPr lang="nl-NL" smtClean="0"/>
-              <a:t>8-4-2026</a:t>
+              <a:t>14-4-2026</a:t>
             </a:fld>
             <a:endParaRPr lang="nl-NL"/>
           </a:p>
@@ -1490,7 +1578,7 @@
           <a:p>
             <a:fld id="{AED78EE6-7C35-42AA-BCAB-EACF262A9D8B}" type="datetimeFigureOut">
               <a:rPr lang="nl-NL" smtClean="0"/>
-              <a:t>8-4-2026</a:t>
+              <a:t>14-4-2026</a:t>
             </a:fld>
             <a:endParaRPr lang="nl-NL"/>
           </a:p>
@@ -1905,7 +1993,7 @@
           <a:p>
             <a:fld id="{AED78EE6-7C35-42AA-BCAB-EACF262A9D8B}" type="datetimeFigureOut">
               <a:rPr lang="nl-NL" smtClean="0"/>
-              <a:t>8-4-2026</a:t>
+              <a:t>14-4-2026</a:t>
             </a:fld>
             <a:endParaRPr lang="nl-NL"/>
           </a:p>
@@ -2047,7 +2135,7 @@
           <a:p>
             <a:fld id="{AED78EE6-7C35-42AA-BCAB-EACF262A9D8B}" type="datetimeFigureOut">
               <a:rPr lang="nl-NL" smtClean="0"/>
-              <a:t>8-4-2026</a:t>
+              <a:t>14-4-2026</a:t>
             </a:fld>
             <a:endParaRPr lang="nl-NL"/>
           </a:p>
@@ -2160,7 +2248,7 @@
           <a:p>
             <a:fld id="{AED78EE6-7C35-42AA-BCAB-EACF262A9D8B}" type="datetimeFigureOut">
               <a:rPr lang="nl-NL" smtClean="0"/>
-              <a:t>8-4-2026</a:t>
+              <a:t>14-4-2026</a:t>
             </a:fld>
             <a:endParaRPr lang="nl-NL"/>
           </a:p>
@@ -2473,7 +2561,7 @@
           <a:p>
             <a:fld id="{AED78EE6-7C35-42AA-BCAB-EACF262A9D8B}" type="datetimeFigureOut">
               <a:rPr lang="nl-NL" smtClean="0"/>
-              <a:t>8-4-2026</a:t>
+              <a:t>14-4-2026</a:t>
             </a:fld>
             <a:endParaRPr lang="nl-NL"/>
           </a:p>
@@ -2762,7 +2850,7 @@
           <a:p>
             <a:fld id="{AED78EE6-7C35-42AA-BCAB-EACF262A9D8B}" type="datetimeFigureOut">
               <a:rPr lang="nl-NL" smtClean="0"/>
-              <a:t>8-4-2026</a:t>
+              <a:t>14-4-2026</a:t>
             </a:fld>
             <a:endParaRPr lang="nl-NL"/>
           </a:p>
@@ -3005,7 +3093,7 @@
           <a:p>
             <a:fld id="{AED78EE6-7C35-42AA-BCAB-EACF262A9D8B}" type="datetimeFigureOut">
               <a:rPr lang="nl-NL" smtClean="0"/>
-              <a:t>8-4-2026</a:t>
+              <a:t>14-4-2026</a:t>
             </a:fld>
             <a:endParaRPr lang="nl-NL"/>
           </a:p>

</xml_diff>

<commit_message>
29-04-2026 - Weekly Update
</commit_message>
<xml_diff>
--- a/Website pic standardization.pptx
+++ b/Website pic standardization.pptx
@@ -129,7 +129,7 @@
 <file path=ppt/revisionInfo.xml><?xml version="1.0" encoding="utf-8"?>
 <p1510:revInfo xmlns:a="http://schemas.openxmlformats.org/drawingml/2006/main" xmlns:r="http://schemas.openxmlformats.org/officeDocument/2006/relationships" xmlns:p1510="http://schemas.microsoft.com/office/powerpoint/2015/10/main">
   <p1510:revLst>
-    <p1510:client id="{35689674-3667-4C05-8271-F9F74B4BE6DC}" v="102" dt="2026-04-14T08:42:54.984"/>
+    <p1510:client id="{35689674-3667-4C05-8271-F9F74B4BE6DC}" v="120" dt="2026-04-29T09:19:51.184"/>
   </p1510:revLst>
 </p1510:revInfo>
 </file>
@@ -139,18 +139,18 @@
   <pc:docChgLst>
     <pc:chgData name="Andrea Caspani" userId="7345b5ed-8b71-432a-9bb0-dc2ce0ac91b1" providerId="ADAL" clId="{B76F09E3-2273-4519-9469-188BBF2C42C4}"/>
     <pc:docChg chg="undo custSel modSld">
-      <pc:chgData name="Andrea Caspani" userId="7345b5ed-8b71-432a-9bb0-dc2ce0ac91b1" providerId="ADAL" clId="{B76F09E3-2273-4519-9469-188BBF2C42C4}" dt="2026-04-14T08:43:00.617" v="292" actId="478"/>
+      <pc:chgData name="Andrea Caspani" userId="7345b5ed-8b71-432a-9bb0-dc2ce0ac91b1" providerId="ADAL" clId="{B76F09E3-2273-4519-9469-188BBF2C42C4}" dt="2026-04-29T09:19:50.720" v="332" actId="1076"/>
       <pc:docMkLst>
         <pc:docMk/>
       </pc:docMkLst>
       <pc:sldChg chg="addSp delSp modSp mod">
-        <pc:chgData name="Andrea Caspani" userId="7345b5ed-8b71-432a-9bb0-dc2ce0ac91b1" providerId="ADAL" clId="{B76F09E3-2273-4519-9469-188BBF2C42C4}" dt="2026-04-14T08:43:00.617" v="292" actId="478"/>
+        <pc:chgData name="Andrea Caspani" userId="7345b5ed-8b71-432a-9bb0-dc2ce0ac91b1" providerId="ADAL" clId="{B76F09E3-2273-4519-9469-188BBF2C42C4}" dt="2026-04-29T09:19:50.720" v="332" actId="1076"/>
         <pc:sldMkLst>
           <pc:docMk/>
           <pc:sldMk cId="3775944948" sldId="258"/>
         </pc:sldMkLst>
         <pc:spChg chg="add del mod ord topLvl">
-          <ac:chgData name="Andrea Caspani" userId="7345b5ed-8b71-432a-9bb0-dc2ce0ac91b1" providerId="ADAL" clId="{B76F09E3-2273-4519-9469-188BBF2C42C4}" dt="2026-04-14T08:42:55.417" v="286" actId="207"/>
+          <ac:chgData name="Andrea Caspani" userId="7345b5ed-8b71-432a-9bb0-dc2ce0ac91b1" providerId="ADAL" clId="{B76F09E3-2273-4519-9469-188BBF2C42C4}" dt="2026-04-29T09:19:49.709" v="328" actId="207"/>
           <ac:spMkLst>
             <pc:docMk/>
             <pc:sldMk cId="3775944948" sldId="258"/>
@@ -158,115 +158,35 @@
           </ac:spMkLst>
         </pc:spChg>
         <pc:grpChg chg="add mod">
-          <ac:chgData name="Andrea Caspani" userId="7345b5ed-8b71-432a-9bb0-dc2ce0ac91b1" providerId="ADAL" clId="{B76F09E3-2273-4519-9469-188BBF2C42C4}" dt="2026-04-14T08:41:07.941" v="254" actId="164"/>
+          <ac:chgData name="Andrea Caspani" userId="7345b5ed-8b71-432a-9bb0-dc2ce0ac91b1" providerId="ADAL" clId="{B76F09E3-2273-4519-9469-188BBF2C42C4}" dt="2026-04-29T09:11:07.028" v="304" actId="164"/>
           <ac:grpSpMkLst>
             <pc:docMk/>
             <pc:sldMk cId="3775944948" sldId="258"/>
-            <ac:grpSpMk id="15" creationId="{F0144A51-A481-7937-BDBC-F132A67F2CEA}"/>
+            <ac:grpSpMk id="5" creationId="{14252037-6AA0-A811-2F45-1CC3B8D51492}"/>
           </ac:grpSpMkLst>
         </pc:grpChg>
         <pc:grpChg chg="add mod">
-          <ac:chgData name="Andrea Caspani" userId="7345b5ed-8b71-432a-9bb0-dc2ce0ac91b1" providerId="ADAL" clId="{B76F09E3-2273-4519-9469-188BBF2C42C4}" dt="2026-04-14T08:42:54.984" v="284" actId="164"/>
+          <ac:chgData name="Andrea Caspani" userId="7345b5ed-8b71-432a-9bb0-dc2ce0ac91b1" providerId="ADAL" clId="{B76F09E3-2273-4519-9469-188BBF2C42C4}" dt="2026-04-29T09:19:49.547" v="327" actId="164"/>
           <ac:grpSpMkLst>
             <pc:docMk/>
             <pc:sldMk cId="3775944948" sldId="258"/>
-            <ac:grpSpMk id="18" creationId="{C18FA42D-C5C5-585F-67DD-2CF9FAC5F616}"/>
+            <ac:grpSpMk id="6" creationId="{9478571E-3565-F1C8-4CDF-FA3DF06EBA67}"/>
           </ac:grpSpMkLst>
         </pc:grpChg>
-        <pc:picChg chg="add del mod ord">
-          <ac:chgData name="Andrea Caspani" userId="7345b5ed-8b71-432a-9bb0-dc2ce0ac91b1" providerId="ADAL" clId="{B76F09E3-2273-4519-9469-188BBF2C42C4}" dt="2026-04-14T08:41:13.437" v="269" actId="478"/>
+        <pc:picChg chg="add del mod modCrop">
+          <ac:chgData name="Andrea Caspani" userId="7345b5ed-8b71-432a-9bb0-dc2ce0ac91b1" providerId="ADAL" clId="{B76F09E3-2273-4519-9469-188BBF2C42C4}" dt="2026-04-29T09:11:09.867" v="313" actId="931"/>
           <ac:picMkLst>
             <pc:docMk/>
             <pc:sldMk cId="3775944948" sldId="258"/>
-            <ac:picMk id="3" creationId="{DD7C83CF-96DB-D7DB-F1C0-212AB9B1EE2A}"/>
+            <ac:picMk id="3" creationId="{19A805EF-AC68-FD96-5A93-854BD203FDA6}"/>
           </ac:picMkLst>
         </pc:picChg>
-        <pc:picChg chg="add del mod">
-          <ac:chgData name="Andrea Caspani" userId="7345b5ed-8b71-432a-9bb0-dc2ce0ac91b1" providerId="ADAL" clId="{B76F09E3-2273-4519-9469-188BBF2C42C4}" dt="2026-04-14T08:41:14.107" v="270" actId="478"/>
+        <pc:picChg chg="add mod">
+          <ac:chgData name="Andrea Caspani" userId="7345b5ed-8b71-432a-9bb0-dc2ce0ac91b1" providerId="ADAL" clId="{B76F09E3-2273-4519-9469-188BBF2C42C4}" dt="2026-04-29T09:19:50.720" v="332" actId="1076"/>
           <ac:picMkLst>
             <pc:docMk/>
             <pc:sldMk cId="3775944948" sldId="258"/>
-            <ac:picMk id="5" creationId="{26F9A092-631B-647E-C4B7-32F7D4F87E1D}"/>
-          </ac:picMkLst>
-        </pc:picChg>
-        <pc:picChg chg="add del mod">
-          <ac:chgData name="Andrea Caspani" userId="7345b5ed-8b71-432a-9bb0-dc2ce0ac91b1" providerId="ADAL" clId="{B76F09E3-2273-4519-9469-188BBF2C42C4}" dt="2026-04-14T08:41:12.643" v="268" actId="478"/>
-          <ac:picMkLst>
-            <pc:docMk/>
-            <pc:sldMk cId="3775944948" sldId="258"/>
-            <ac:picMk id="6" creationId="{F84C1B55-1C3C-3F40-59EF-8D3A0FF89839}"/>
-          </ac:picMkLst>
-        </pc:picChg>
-        <pc:picChg chg="add del mod ord modCrop">
-          <ac:chgData name="Andrea Caspani" userId="7345b5ed-8b71-432a-9bb0-dc2ce0ac91b1" providerId="ADAL" clId="{B76F09E3-2273-4519-9469-188BBF2C42C4}" dt="2026-04-14T08:41:11.035" v="267" actId="478"/>
-          <ac:picMkLst>
-            <pc:docMk/>
-            <pc:sldMk cId="3775944948" sldId="258"/>
-            <ac:picMk id="7" creationId="{0F2DF81F-C03E-C6F1-5B6B-B5183E234934}"/>
-          </ac:picMkLst>
-        </pc:picChg>
-        <pc:picChg chg="add del mod modCrop">
-          <ac:chgData name="Andrea Caspani" userId="7345b5ed-8b71-432a-9bb0-dc2ce0ac91b1" providerId="ADAL" clId="{B76F09E3-2273-4519-9469-188BBF2C42C4}" dt="2026-04-14T08:41:16.232" v="273" actId="478"/>
-          <ac:picMkLst>
-            <pc:docMk/>
-            <pc:sldMk cId="3775944948" sldId="258"/>
-            <ac:picMk id="8" creationId="{D6D02F7B-0AEE-B031-D50F-F099BAF696FF}"/>
-          </ac:picMkLst>
-        </pc:picChg>
-        <pc:picChg chg="add del mod modCrop">
-          <ac:chgData name="Andrea Caspani" userId="7345b5ed-8b71-432a-9bb0-dc2ce0ac91b1" providerId="ADAL" clId="{B76F09E3-2273-4519-9469-188BBF2C42C4}" dt="2026-04-14T08:41:15.550" v="272" actId="478"/>
-          <ac:picMkLst>
-            <pc:docMk/>
-            <pc:sldMk cId="3775944948" sldId="258"/>
-            <ac:picMk id="9" creationId="{A59E1CE6-4E05-7F10-639F-3C80B81348EC}"/>
-          </ac:picMkLst>
-        </pc:picChg>
-        <pc:picChg chg="add del mod">
-          <ac:chgData name="Andrea Caspani" userId="7345b5ed-8b71-432a-9bb0-dc2ce0ac91b1" providerId="ADAL" clId="{B76F09E3-2273-4519-9469-188BBF2C42C4}" dt="2026-04-14T08:41:14.853" v="271" actId="478"/>
-          <ac:picMkLst>
-            <pc:docMk/>
-            <pc:sldMk cId="3775944948" sldId="258"/>
-            <ac:picMk id="10" creationId="{4C0BD197-7F58-9DC1-E21A-9C9C904D1829}"/>
-          </ac:picMkLst>
-        </pc:picChg>
-        <pc:picChg chg="add del mod ord">
-          <ac:chgData name="Andrea Caspani" userId="7345b5ed-8b71-432a-9bb0-dc2ce0ac91b1" providerId="ADAL" clId="{B76F09E3-2273-4519-9469-188BBF2C42C4}" dt="2026-04-14T08:43:00.617" v="292" actId="478"/>
-          <ac:picMkLst>
-            <pc:docMk/>
-            <pc:sldMk cId="3775944948" sldId="258"/>
-            <ac:picMk id="11" creationId="{722B65EB-910E-06F7-391E-3025A7CF6CDD}"/>
-          </ac:picMkLst>
-        </pc:picChg>
-        <pc:picChg chg="add mod ord">
-          <ac:chgData name="Andrea Caspani" userId="7345b5ed-8b71-432a-9bb0-dc2ce0ac91b1" providerId="ADAL" clId="{B76F09E3-2273-4519-9469-188BBF2C42C4}" dt="2026-04-14T08:41:08.840" v="258" actId="166"/>
-          <ac:picMkLst>
-            <pc:docMk/>
-            <pc:sldMk cId="3775944948" sldId="258"/>
-            <ac:picMk id="12" creationId="{0F2DF81F-C03E-C6F1-5B6B-B5183E234934}"/>
-          </ac:picMkLst>
-        </pc:picChg>
-        <pc:picChg chg="add mod">
-          <ac:chgData name="Andrea Caspani" userId="7345b5ed-8b71-432a-9bb0-dc2ce0ac91b1" providerId="ADAL" clId="{B76F09E3-2273-4519-9469-188BBF2C42C4}" dt="2026-04-14T08:39:56.806" v="249"/>
-          <ac:picMkLst>
-            <pc:docMk/>
-            <pc:sldMk cId="3775944948" sldId="258"/>
-            <ac:picMk id="13" creationId="{DD7C83CF-96DB-D7DB-F1C0-212AB9B1EE2A}"/>
-          </ac:picMkLst>
-        </pc:picChg>
-        <pc:picChg chg="add mod">
-          <ac:chgData name="Andrea Caspani" userId="7345b5ed-8b71-432a-9bb0-dc2ce0ac91b1" providerId="ADAL" clId="{B76F09E3-2273-4519-9469-188BBF2C42C4}" dt="2026-04-14T08:41:07.941" v="254" actId="164"/>
-          <ac:picMkLst>
-            <pc:docMk/>
-            <pc:sldMk cId="3775944948" sldId="258"/>
-            <ac:picMk id="14" creationId="{E67D9297-80AE-F590-48F6-7974A1ED5B6E}"/>
-          </ac:picMkLst>
-        </pc:picChg>
-        <pc:picChg chg="add del mod">
-          <ac:chgData name="Andrea Caspani" userId="7345b5ed-8b71-432a-9bb0-dc2ce0ac91b1" providerId="ADAL" clId="{B76F09E3-2273-4519-9469-188BBF2C42C4}" dt="2026-04-14T08:42:57.310" v="291" actId="931"/>
-          <ac:picMkLst>
-            <pc:docMk/>
-            <pc:sldMk cId="3775944948" sldId="258"/>
-            <ac:picMk id="17" creationId="{FFE0BD10-3350-D124-9E9C-5844F2344546}"/>
+            <ac:picMk id="1026" creationId="{405A4115-6A01-4342-F5B5-4699F6EA8573}"/>
           </ac:picMkLst>
         </pc:picChg>
       </pc:sldChg>
@@ -424,7 +344,7 @@
           <a:p>
             <a:fld id="{AED78EE6-7C35-42AA-BCAB-EACF262A9D8B}" type="datetimeFigureOut">
               <a:rPr lang="nl-NL" smtClean="0"/>
-              <a:t>14-4-2026</a:t>
+              <a:t>29-4-2026</a:t>
             </a:fld>
             <a:endParaRPr lang="nl-NL"/>
           </a:p>
@@ -624,7 +544,7 @@
           <a:p>
             <a:fld id="{AED78EE6-7C35-42AA-BCAB-EACF262A9D8B}" type="datetimeFigureOut">
               <a:rPr lang="nl-NL" smtClean="0"/>
-              <a:t>14-4-2026</a:t>
+              <a:t>29-4-2026</a:t>
             </a:fld>
             <a:endParaRPr lang="nl-NL"/>
           </a:p>
@@ -834,7 +754,7 @@
           <a:p>
             <a:fld id="{AED78EE6-7C35-42AA-BCAB-EACF262A9D8B}" type="datetimeFigureOut">
               <a:rPr lang="nl-NL" smtClean="0"/>
-              <a:t>14-4-2026</a:t>
+              <a:t>29-4-2026</a:t>
             </a:fld>
             <a:endParaRPr lang="nl-NL"/>
           </a:p>
@@ -1034,7 +954,7 @@
           <a:p>
             <a:fld id="{AED78EE6-7C35-42AA-BCAB-EACF262A9D8B}" type="datetimeFigureOut">
               <a:rPr lang="nl-NL" smtClean="0"/>
-              <a:t>14-4-2026</a:t>
+              <a:t>29-4-2026</a:t>
             </a:fld>
             <a:endParaRPr lang="nl-NL"/>
           </a:p>
@@ -1310,7 +1230,7 @@
           <a:p>
             <a:fld id="{AED78EE6-7C35-42AA-BCAB-EACF262A9D8B}" type="datetimeFigureOut">
               <a:rPr lang="nl-NL" smtClean="0"/>
-              <a:t>14-4-2026</a:t>
+              <a:t>29-4-2026</a:t>
             </a:fld>
             <a:endParaRPr lang="nl-NL"/>
           </a:p>
@@ -1578,7 +1498,7 @@
           <a:p>
             <a:fld id="{AED78EE6-7C35-42AA-BCAB-EACF262A9D8B}" type="datetimeFigureOut">
               <a:rPr lang="nl-NL" smtClean="0"/>
-              <a:t>14-4-2026</a:t>
+              <a:t>29-4-2026</a:t>
             </a:fld>
             <a:endParaRPr lang="nl-NL"/>
           </a:p>
@@ -1993,7 +1913,7 @@
           <a:p>
             <a:fld id="{AED78EE6-7C35-42AA-BCAB-EACF262A9D8B}" type="datetimeFigureOut">
               <a:rPr lang="nl-NL" smtClean="0"/>
-              <a:t>14-4-2026</a:t>
+              <a:t>29-4-2026</a:t>
             </a:fld>
             <a:endParaRPr lang="nl-NL"/>
           </a:p>
@@ -2135,7 +2055,7 @@
           <a:p>
             <a:fld id="{AED78EE6-7C35-42AA-BCAB-EACF262A9D8B}" type="datetimeFigureOut">
               <a:rPr lang="nl-NL" smtClean="0"/>
-              <a:t>14-4-2026</a:t>
+              <a:t>29-4-2026</a:t>
             </a:fld>
             <a:endParaRPr lang="nl-NL"/>
           </a:p>
@@ -2248,7 +2168,7 @@
           <a:p>
             <a:fld id="{AED78EE6-7C35-42AA-BCAB-EACF262A9D8B}" type="datetimeFigureOut">
               <a:rPr lang="nl-NL" smtClean="0"/>
-              <a:t>14-4-2026</a:t>
+              <a:t>29-4-2026</a:t>
             </a:fld>
             <a:endParaRPr lang="nl-NL"/>
           </a:p>
@@ -2561,7 +2481,7 @@
           <a:p>
             <a:fld id="{AED78EE6-7C35-42AA-BCAB-EACF262A9D8B}" type="datetimeFigureOut">
               <a:rPr lang="nl-NL" smtClean="0"/>
-              <a:t>14-4-2026</a:t>
+              <a:t>29-4-2026</a:t>
             </a:fld>
             <a:endParaRPr lang="nl-NL"/>
           </a:p>
@@ -2850,7 +2770,7 @@
           <a:p>
             <a:fld id="{AED78EE6-7C35-42AA-BCAB-EACF262A9D8B}" type="datetimeFigureOut">
               <a:rPr lang="nl-NL" smtClean="0"/>
-              <a:t>14-4-2026</a:t>
+              <a:t>29-4-2026</a:t>
             </a:fld>
             <a:endParaRPr lang="nl-NL"/>
           </a:p>
@@ -3093,7 +3013,7 @@
           <a:p>
             <a:fld id="{AED78EE6-7C35-42AA-BCAB-EACF262A9D8B}" type="datetimeFigureOut">
               <a:rPr lang="nl-NL" smtClean="0"/>
-              <a:t>14-4-2026</a:t>
+              <a:t>29-4-2026</a:t>
             </a:fld>
             <a:endParaRPr lang="nl-NL"/>
           </a:p>

</xml_diff>

<commit_message>
04-05-2026 - Weekly Update
</commit_message>
<xml_diff>
--- a/Website pic standardization.pptx
+++ b/Website pic standardization.pptx
@@ -129,7 +129,7 @@
 <file path=ppt/revisionInfo.xml><?xml version="1.0" encoding="utf-8"?>
 <p1510:revInfo xmlns:a="http://schemas.openxmlformats.org/drawingml/2006/main" xmlns:r="http://schemas.openxmlformats.org/officeDocument/2006/relationships" xmlns:p1510="http://schemas.microsoft.com/office/powerpoint/2015/10/main">
   <p1510:revLst>
-    <p1510:client id="{35689674-3667-4C05-8271-F9F74B4BE6DC}" v="120" dt="2026-04-29T09:19:51.184"/>
+    <p1510:client id="{35689674-3667-4C05-8271-F9F74B4BE6DC}" v="124" dt="2026-05-04T15:13:14.926"/>
   </p1510:revLst>
 </p1510:revInfo>
 </file>
@@ -139,54 +139,126 @@
   <pc:docChgLst>
     <pc:chgData name="Andrea Caspani" userId="7345b5ed-8b71-432a-9bb0-dc2ce0ac91b1" providerId="ADAL" clId="{B76F09E3-2273-4519-9469-188BBF2C42C4}"/>
     <pc:docChg chg="undo custSel modSld">
-      <pc:chgData name="Andrea Caspani" userId="7345b5ed-8b71-432a-9bb0-dc2ce0ac91b1" providerId="ADAL" clId="{B76F09E3-2273-4519-9469-188BBF2C42C4}" dt="2026-04-29T09:19:50.720" v="332" actId="1076"/>
+      <pc:chgData name="Andrea Caspani" userId="7345b5ed-8b71-432a-9bb0-dc2ce0ac91b1" providerId="ADAL" clId="{B76F09E3-2273-4519-9469-188BBF2C42C4}" dt="2026-05-04T15:30:12.451" v="425" actId="478"/>
       <pc:docMkLst>
         <pc:docMk/>
       </pc:docMkLst>
       <pc:sldChg chg="addSp delSp modSp mod">
-        <pc:chgData name="Andrea Caspani" userId="7345b5ed-8b71-432a-9bb0-dc2ce0ac91b1" providerId="ADAL" clId="{B76F09E3-2273-4519-9469-188BBF2C42C4}" dt="2026-04-29T09:19:50.720" v="332" actId="1076"/>
+        <pc:chgData name="Andrea Caspani" userId="7345b5ed-8b71-432a-9bb0-dc2ce0ac91b1" providerId="ADAL" clId="{B76F09E3-2273-4519-9469-188BBF2C42C4}" dt="2026-05-04T15:30:12.451" v="425" actId="478"/>
         <pc:sldMkLst>
           <pc:docMk/>
           <pc:sldMk cId="3775944948" sldId="258"/>
         </pc:sldMkLst>
+        <pc:spChg chg="add">
+          <ac:chgData name="Andrea Caspani" userId="7345b5ed-8b71-432a-9bb0-dc2ce0ac91b1" providerId="ADAL" clId="{B76F09E3-2273-4519-9469-188BBF2C42C4}" dt="2026-05-04T15:25:40.005" v="363"/>
+          <ac:spMkLst>
+            <pc:docMk/>
+            <pc:sldMk cId="3775944948" sldId="258"/>
+            <ac:spMk id="2" creationId="{F2DDDB99-D266-151B-233C-3B0B3DD18F60}"/>
+          </ac:spMkLst>
+        </pc:spChg>
         <pc:spChg chg="add del mod ord topLvl">
-          <ac:chgData name="Andrea Caspani" userId="7345b5ed-8b71-432a-9bb0-dc2ce0ac91b1" providerId="ADAL" clId="{B76F09E3-2273-4519-9469-188BBF2C42C4}" dt="2026-04-29T09:19:49.709" v="328" actId="207"/>
+          <ac:chgData name="Andrea Caspani" userId="7345b5ed-8b71-432a-9bb0-dc2ce0ac91b1" providerId="ADAL" clId="{B76F09E3-2273-4519-9469-188BBF2C42C4}" dt="2026-05-04T15:30:06.153" v="404" actId="207"/>
           <ac:spMkLst>
             <pc:docMk/>
             <pc:sldMk cId="3775944948" sldId="258"/>
             <ac:spMk id="4" creationId="{A4B43D83-03A1-8289-E760-4AF948E0C4F9}"/>
           </ac:spMkLst>
         </pc:spChg>
+        <pc:spChg chg="add">
+          <ac:chgData name="Andrea Caspani" userId="7345b5ed-8b71-432a-9bb0-dc2ce0ac91b1" providerId="ADAL" clId="{B76F09E3-2273-4519-9469-188BBF2C42C4}" dt="2026-05-04T15:12:15.232" v="346"/>
+          <ac:spMkLst>
+            <pc:docMk/>
+            <pc:sldMk cId="3775944948" sldId="258"/>
+            <ac:spMk id="5" creationId="{7251C956-C7E4-A6C1-B801-99C5DD74F24E}"/>
+          </ac:spMkLst>
+        </pc:spChg>
+        <pc:spChg chg="add">
+          <ac:chgData name="Andrea Caspani" userId="7345b5ed-8b71-432a-9bb0-dc2ce0ac91b1" providerId="ADAL" clId="{B76F09E3-2273-4519-9469-188BBF2C42C4}" dt="2026-05-04T15:25:51.789" v="368"/>
+          <ac:spMkLst>
+            <pc:docMk/>
+            <pc:sldMk cId="3775944948" sldId="258"/>
+            <ac:spMk id="6" creationId="{5DAAF77F-78C6-330C-0F7D-D6AB55E9E6F5}"/>
+          </ac:spMkLst>
+        </pc:spChg>
+        <pc:spChg chg="add">
+          <ac:chgData name="Andrea Caspani" userId="7345b5ed-8b71-432a-9bb0-dc2ce0ac91b1" providerId="ADAL" clId="{B76F09E3-2273-4519-9469-188BBF2C42C4}" dt="2026-05-04T15:26:09.443" v="376"/>
+          <ac:spMkLst>
+            <pc:docMk/>
+            <pc:sldMk cId="3775944948" sldId="258"/>
+            <ac:spMk id="9" creationId="{DCDF0193-18A6-60AF-00C1-4FE412624C58}"/>
+          </ac:spMkLst>
+        </pc:spChg>
+        <pc:spChg chg="add">
+          <ac:chgData name="Andrea Caspani" userId="7345b5ed-8b71-432a-9bb0-dc2ce0ac91b1" providerId="ADAL" clId="{B76F09E3-2273-4519-9469-188BBF2C42C4}" dt="2026-05-04T15:26:37.503" v="384"/>
+          <ac:spMkLst>
+            <pc:docMk/>
+            <pc:sldMk cId="3775944948" sldId="258"/>
+            <ac:spMk id="12" creationId="{3156743D-369D-CAA0-30A1-9D6B8BC1E595}"/>
+          </ac:spMkLst>
+        </pc:spChg>
         <pc:grpChg chg="add mod">
-          <ac:chgData name="Andrea Caspani" userId="7345b5ed-8b71-432a-9bb0-dc2ce0ac91b1" providerId="ADAL" clId="{B76F09E3-2273-4519-9469-188BBF2C42C4}" dt="2026-04-29T09:11:07.028" v="304" actId="164"/>
+          <ac:chgData name="Andrea Caspani" userId="7345b5ed-8b71-432a-9bb0-dc2ce0ac91b1" providerId="ADAL" clId="{B76F09E3-2273-4519-9469-188BBF2C42C4}" dt="2026-05-04T15:13:14.926" v="355" actId="164"/>
           <ac:grpSpMkLst>
             <pc:docMk/>
             <pc:sldMk cId="3775944948" sldId="258"/>
-            <ac:grpSpMk id="5" creationId="{14252037-6AA0-A811-2F45-1CC3B8D51492}"/>
+            <ac:grpSpMk id="8" creationId="{B1B4834A-625C-67D6-F219-553AF9283C32}"/>
           </ac:grpSpMkLst>
         </pc:grpChg>
         <pc:grpChg chg="add mod">
-          <ac:chgData name="Andrea Caspani" userId="7345b5ed-8b71-432a-9bb0-dc2ce0ac91b1" providerId="ADAL" clId="{B76F09E3-2273-4519-9469-188BBF2C42C4}" dt="2026-04-29T09:19:49.547" v="327" actId="164"/>
+          <ac:chgData name="Andrea Caspani" userId="7345b5ed-8b71-432a-9bb0-dc2ce0ac91b1" providerId="ADAL" clId="{B76F09E3-2273-4519-9469-188BBF2C42C4}" dt="2026-05-04T15:30:05.964" v="403" actId="164"/>
           <ac:grpSpMkLst>
             <pc:docMk/>
             <pc:sldMk cId="3775944948" sldId="258"/>
-            <ac:grpSpMk id="6" creationId="{9478571E-3565-F1C8-4CDF-FA3DF06EBA67}"/>
+            <ac:grpSpMk id="15" creationId="{119534DB-0983-1A49-1479-FAE8FFFB63DD}"/>
           </ac:grpSpMkLst>
         </pc:grpChg>
-        <pc:picChg chg="add del mod modCrop">
-          <ac:chgData name="Andrea Caspani" userId="7345b5ed-8b71-432a-9bb0-dc2ce0ac91b1" providerId="ADAL" clId="{B76F09E3-2273-4519-9469-188BBF2C42C4}" dt="2026-04-29T09:11:09.867" v="313" actId="931"/>
+        <pc:picChg chg="add del mod">
+          <ac:chgData name="Andrea Caspani" userId="7345b5ed-8b71-432a-9bb0-dc2ce0ac91b1" providerId="ADAL" clId="{B76F09E3-2273-4519-9469-188BBF2C42C4}" dt="2026-05-04T15:12:14.491" v="345" actId="478"/>
           <ac:picMkLst>
             <pc:docMk/>
             <pc:sldMk cId="3775944948" sldId="258"/>
-            <ac:picMk id="3" creationId="{19A805EF-AC68-FD96-5A93-854BD203FDA6}"/>
+            <ac:picMk id="3" creationId="{260867C2-CE73-C30B-6C5B-1D2DAE4F8507}"/>
           </ac:picMkLst>
         </pc:picChg>
-        <pc:picChg chg="add mod">
-          <ac:chgData name="Andrea Caspani" userId="7345b5ed-8b71-432a-9bb0-dc2ce0ac91b1" providerId="ADAL" clId="{B76F09E3-2273-4519-9469-188BBF2C42C4}" dt="2026-04-29T09:19:50.720" v="332" actId="1076"/>
+        <pc:picChg chg="add del mod">
+          <ac:chgData name="Andrea Caspani" userId="7345b5ed-8b71-432a-9bb0-dc2ce0ac91b1" providerId="ADAL" clId="{B76F09E3-2273-4519-9469-188BBF2C42C4}" dt="2026-05-04T15:30:12.451" v="425" actId="478"/>
           <ac:picMkLst>
             <pc:docMk/>
             <pc:sldMk cId="3775944948" sldId="258"/>
-            <ac:picMk id="1026" creationId="{405A4115-6A01-4342-F5B5-4699F6EA8573}"/>
+            <ac:picMk id="5" creationId="{DAB16ABC-D124-610F-3D8F-2E079B138D6E}"/>
+          </ac:picMkLst>
+        </pc:picChg>
+        <pc:picChg chg="add del mod">
+          <ac:chgData name="Andrea Caspani" userId="7345b5ed-8b71-432a-9bb0-dc2ce0ac91b1" providerId="ADAL" clId="{B76F09E3-2273-4519-9469-188BBF2C42C4}" dt="2026-05-04T15:13:17.166" v="362" actId="22"/>
+          <ac:picMkLst>
+            <pc:docMk/>
+            <pc:sldMk cId="3775944948" sldId="258"/>
+            <ac:picMk id="7" creationId="{790C36DB-8573-ACEC-3D4D-DC2662F79C6C}"/>
+          </ac:picMkLst>
+        </pc:picChg>
+        <pc:picChg chg="add del mod">
+          <ac:chgData name="Andrea Caspani" userId="7345b5ed-8b71-432a-9bb0-dc2ce0ac91b1" providerId="ADAL" clId="{B76F09E3-2273-4519-9469-188BBF2C42C4}" dt="2026-05-04T15:30:11.488" v="423" actId="478"/>
+          <ac:picMkLst>
+            <pc:docMk/>
+            <pc:sldMk cId="3775944948" sldId="258"/>
+            <ac:picMk id="8" creationId="{8906A618-DF31-0781-A449-DC573BF539DC}"/>
+          </ac:picMkLst>
+        </pc:picChg>
+        <pc:picChg chg="add del mod">
+          <ac:chgData name="Andrea Caspani" userId="7345b5ed-8b71-432a-9bb0-dc2ce0ac91b1" providerId="ADAL" clId="{B76F09E3-2273-4519-9469-188BBF2C42C4}" dt="2026-05-04T15:30:12.051" v="424" actId="478"/>
+          <ac:picMkLst>
+            <pc:docMk/>
+            <pc:sldMk cId="3775944948" sldId="258"/>
+            <ac:picMk id="11" creationId="{C6743E33-2016-AD4B-664B-72E4D8FB1582}"/>
+          </ac:picMkLst>
+        </pc:picChg>
+        <pc:picChg chg="add del mod modCrop">
+          <ac:chgData name="Andrea Caspani" userId="7345b5ed-8b71-432a-9bb0-dc2ce0ac91b1" providerId="ADAL" clId="{B76F09E3-2273-4519-9469-188BBF2C42C4}" dt="2026-05-04T15:30:09.257" v="420" actId="22"/>
+          <ac:picMkLst>
+            <pc:docMk/>
+            <pc:sldMk cId="3775944948" sldId="258"/>
+            <ac:picMk id="14" creationId="{6EE6AEA1-A919-9A5E-B335-DAAF1789E15A}"/>
           </ac:picMkLst>
         </pc:picChg>
       </pc:sldChg>
@@ -344,7 +416,7 @@
           <a:p>
             <a:fld id="{AED78EE6-7C35-42AA-BCAB-EACF262A9D8B}" type="datetimeFigureOut">
               <a:rPr lang="nl-NL" smtClean="0"/>
-              <a:t>29-4-2026</a:t>
+              <a:t>4-5-2026</a:t>
             </a:fld>
             <a:endParaRPr lang="nl-NL"/>
           </a:p>
@@ -544,7 +616,7 @@
           <a:p>
             <a:fld id="{AED78EE6-7C35-42AA-BCAB-EACF262A9D8B}" type="datetimeFigureOut">
               <a:rPr lang="nl-NL" smtClean="0"/>
-              <a:t>29-4-2026</a:t>
+              <a:t>4-5-2026</a:t>
             </a:fld>
             <a:endParaRPr lang="nl-NL"/>
           </a:p>
@@ -754,7 +826,7 @@
           <a:p>
             <a:fld id="{AED78EE6-7C35-42AA-BCAB-EACF262A9D8B}" type="datetimeFigureOut">
               <a:rPr lang="nl-NL" smtClean="0"/>
-              <a:t>29-4-2026</a:t>
+              <a:t>4-5-2026</a:t>
             </a:fld>
             <a:endParaRPr lang="nl-NL"/>
           </a:p>
@@ -954,7 +1026,7 @@
           <a:p>
             <a:fld id="{AED78EE6-7C35-42AA-BCAB-EACF262A9D8B}" type="datetimeFigureOut">
               <a:rPr lang="nl-NL" smtClean="0"/>
-              <a:t>29-4-2026</a:t>
+              <a:t>4-5-2026</a:t>
             </a:fld>
             <a:endParaRPr lang="nl-NL"/>
           </a:p>
@@ -1230,7 +1302,7 @@
           <a:p>
             <a:fld id="{AED78EE6-7C35-42AA-BCAB-EACF262A9D8B}" type="datetimeFigureOut">
               <a:rPr lang="nl-NL" smtClean="0"/>
-              <a:t>29-4-2026</a:t>
+              <a:t>4-5-2026</a:t>
             </a:fld>
             <a:endParaRPr lang="nl-NL"/>
           </a:p>
@@ -1498,7 +1570,7 @@
           <a:p>
             <a:fld id="{AED78EE6-7C35-42AA-BCAB-EACF262A9D8B}" type="datetimeFigureOut">
               <a:rPr lang="nl-NL" smtClean="0"/>
-              <a:t>29-4-2026</a:t>
+              <a:t>4-5-2026</a:t>
             </a:fld>
             <a:endParaRPr lang="nl-NL"/>
           </a:p>
@@ -1913,7 +1985,7 @@
           <a:p>
             <a:fld id="{AED78EE6-7C35-42AA-BCAB-EACF262A9D8B}" type="datetimeFigureOut">
               <a:rPr lang="nl-NL" smtClean="0"/>
-              <a:t>29-4-2026</a:t>
+              <a:t>4-5-2026</a:t>
             </a:fld>
             <a:endParaRPr lang="nl-NL"/>
           </a:p>
@@ -2055,7 +2127,7 @@
           <a:p>
             <a:fld id="{AED78EE6-7C35-42AA-BCAB-EACF262A9D8B}" type="datetimeFigureOut">
               <a:rPr lang="nl-NL" smtClean="0"/>
-              <a:t>29-4-2026</a:t>
+              <a:t>4-5-2026</a:t>
             </a:fld>
             <a:endParaRPr lang="nl-NL"/>
           </a:p>
@@ -2168,7 +2240,7 @@
           <a:p>
             <a:fld id="{AED78EE6-7C35-42AA-BCAB-EACF262A9D8B}" type="datetimeFigureOut">
               <a:rPr lang="nl-NL" smtClean="0"/>
-              <a:t>29-4-2026</a:t>
+              <a:t>4-5-2026</a:t>
             </a:fld>
             <a:endParaRPr lang="nl-NL"/>
           </a:p>
@@ -2481,7 +2553,7 @@
           <a:p>
             <a:fld id="{AED78EE6-7C35-42AA-BCAB-EACF262A9D8B}" type="datetimeFigureOut">
               <a:rPr lang="nl-NL" smtClean="0"/>
-              <a:t>29-4-2026</a:t>
+              <a:t>4-5-2026</a:t>
             </a:fld>
             <a:endParaRPr lang="nl-NL"/>
           </a:p>
@@ -2770,7 +2842,7 @@
           <a:p>
             <a:fld id="{AED78EE6-7C35-42AA-BCAB-EACF262A9D8B}" type="datetimeFigureOut">
               <a:rPr lang="nl-NL" smtClean="0"/>
-              <a:t>29-4-2026</a:t>
+              <a:t>4-5-2026</a:t>
             </a:fld>
             <a:endParaRPr lang="nl-NL"/>
           </a:p>
@@ -3013,7 +3085,7 @@
           <a:p>
             <a:fld id="{AED78EE6-7C35-42AA-BCAB-EACF262A9D8B}" type="datetimeFigureOut">
               <a:rPr lang="nl-NL" smtClean="0"/>
-              <a:t>29-4-2026</a:t>
+              <a:t>4-5-2026</a:t>
             </a:fld>
             <a:endParaRPr lang="nl-NL"/>
           </a:p>

</xml_diff>